<commit_message>
Sync slides to corrected notebook prose: threshold direction + remove dollar figures
- s2: threshold bullet reworded (highest cut holding ≥80% recall, SMOTE context)
- s9: cost table dollar figures removed; threshold-direction bullets corrected (above 0.5, not below)

Co-Authored-By: Claude Opus 4.8 <noreply@anthropic.com>
</commit_message>
<xml_diff>
--- a/Week 1/Wk1_Capstone/group3.pptx
+++ b/Week 1/Wk1_Capstone/group3.pptx
@@ -5,18 +5,18 @@
     <p:sldMasterId id="2147483648" r:id="rId1"/>
   </p:sldMasterIdLst>
   <p:sldIdLst>
-    <p:sldId id="256" r:id="rId2"/>
-    <p:sldId id="257" r:id="rId3"/>
-    <p:sldId id="258" r:id="rId4"/>
-    <p:sldId id="259" r:id="rId5"/>
-    <p:sldId id="260" r:id="rId6"/>
-    <p:sldId id="261" r:id="rId7"/>
-    <p:sldId id="262" r:id="rId8"/>
-    <p:sldId id="263" r:id="rId9"/>
-    <p:sldId id="264" r:id="rId10"/>
-    <p:sldId id="265" r:id="rId11"/>
+    <p:sldId id="256" r:id="rId7"/>
+    <p:sldId id="257" r:id="rId8"/>
+    <p:sldId id="258" r:id="rId9"/>
+    <p:sldId id="259" r:id="rId10"/>
+    <p:sldId id="260" r:id="rId11"/>
+    <p:sldId id="261" r:id="rId12"/>
+    <p:sldId id="262" r:id="rId13"/>
+    <p:sldId id="263" r:id="rId14"/>
+    <p:sldId id="264" r:id="rId15"/>
+    <p:sldId id="265" r:id="rId16"/>
   </p:sldIdLst>
-  <p:sldSz cx="12192000" cy="6858000"/>
+  <p:sldSz cx="12191695" cy="6858000" type="screen4x3"/>
   <p:notesSz cx="6858000" cy="9144000"/>
   <p:defaultTextStyle>
     <a:defPPr>
@@ -113,22 +113,6 @@
       </a:defRPr>
     </a:lvl9pPr>
   </p:defaultTextStyle>
-  <p:extLst>
-    <p:ext uri="{EFAFB233-063F-42B5-8137-9DF3F51BA10A}">
-      <p15:sldGuideLst xmlns:p15="http://schemas.microsoft.com/office/powerpoint/2012/main">
-        <p15:guide id="1" orient="horz" pos="2160">
-          <p15:clr>
-            <a:srgbClr val="A4A3A4"/>
-          </p15:clr>
-        </p15:guide>
-        <p15:guide id="2" pos="2880">
-          <p15:clr>
-            <a:srgbClr val="A4A3A4"/>
-          </p15:clr>
-        </p15:guide>
-      </p15:sldGuideLst>
-    </p:ext>
-  </p:extLst>
 </p:presentation>
 </file>
 
@@ -170,9 +154,10 @@
           <a:lstStyle/>
           <a:p>
             <a:r>
-              <a:rPr lang="en-US"/>
+              <a:rPr lang="en-US" smtClean="0"/>
               <a:t>Click to edit Master title style</a:t>
             </a:r>
+            <a:endParaRPr lang="en-US"/>
           </a:p>
         </p:txBody>
       </p:sp>
@@ -288,9 +273,10 @@
           </a:lstStyle>
           <a:p>
             <a:r>
-              <a:rPr lang="en-US"/>
+              <a:rPr lang="en-US" smtClean="0"/>
               <a:t>Click to edit Master subtitle style</a:t>
             </a:r>
+            <a:endParaRPr lang="en-US"/>
           </a:p>
         </p:txBody>
       </p:sp>
@@ -311,7 +297,7 @@
           <a:p>
             <a:fld id="{5BCAD085-E8A6-8845-BD4E-CB4CCA059FC4}" type="datetimeFigureOut">
               <a:rPr lang="en-US" smtClean="0"/>
-              <a:t>6/19/26</a:t>
+              <a:t>1/27/13</a:t>
             </a:fld>
             <a:endParaRPr lang="en-US"/>
           </a:p>
@@ -405,9 +391,10 @@
           <a:lstStyle/>
           <a:p>
             <a:r>
-              <a:rPr lang="en-US"/>
+              <a:rPr lang="en-US" smtClean="0"/>
               <a:t>Click to edit Master title style</a:t>
             </a:r>
+            <a:endParaRPr lang="en-US"/>
           </a:p>
         </p:txBody>
       </p:sp>
@@ -428,37 +415,38 @@
           <a:p>
             <a:pPr lvl="0"/>
             <a:r>
-              <a:rPr lang="en-US"/>
+              <a:rPr lang="en-US" smtClean="0"/>
               <a:t>Click to edit Master text styles</a:t>
             </a:r>
           </a:p>
           <a:p>
             <a:pPr lvl="1"/>
             <a:r>
-              <a:rPr lang="en-US"/>
+              <a:rPr lang="en-US" smtClean="0"/>
               <a:t>Second level</a:t>
             </a:r>
           </a:p>
           <a:p>
             <a:pPr lvl="2"/>
             <a:r>
-              <a:rPr lang="en-US"/>
+              <a:rPr lang="en-US" smtClean="0"/>
               <a:t>Third level</a:t>
             </a:r>
           </a:p>
           <a:p>
             <a:pPr lvl="3"/>
             <a:r>
-              <a:rPr lang="en-US"/>
+              <a:rPr lang="en-US" smtClean="0"/>
               <a:t>Fourth level</a:t>
             </a:r>
           </a:p>
           <a:p>
             <a:pPr lvl="4"/>
             <a:r>
-              <a:rPr lang="en-US"/>
+              <a:rPr lang="en-US" smtClean="0"/>
               <a:t>Fifth level</a:t>
             </a:r>
+            <a:endParaRPr lang="en-US"/>
           </a:p>
         </p:txBody>
       </p:sp>
@@ -479,7 +467,7 @@
           <a:p>
             <a:fld id="{5BCAD085-E8A6-8845-BD4E-CB4CCA059FC4}" type="datetimeFigureOut">
               <a:rPr lang="en-US" smtClean="0"/>
-              <a:t>6/19/26</a:t>
+              <a:t>1/27/13</a:t>
             </a:fld>
             <a:endParaRPr lang="en-US"/>
           </a:p>
@@ -578,9 +566,10 @@
           <a:lstStyle/>
           <a:p>
             <a:r>
-              <a:rPr lang="en-US"/>
+              <a:rPr lang="en-US" smtClean="0"/>
               <a:t>Click to edit Master title style</a:t>
             </a:r>
+            <a:endParaRPr lang="en-US"/>
           </a:p>
         </p:txBody>
       </p:sp>
@@ -606,37 +595,38 @@
           <a:p>
             <a:pPr lvl="0"/>
             <a:r>
-              <a:rPr lang="en-US"/>
+              <a:rPr lang="en-US" smtClean="0"/>
               <a:t>Click to edit Master text styles</a:t>
             </a:r>
           </a:p>
           <a:p>
             <a:pPr lvl="1"/>
             <a:r>
-              <a:rPr lang="en-US"/>
+              <a:rPr lang="en-US" smtClean="0"/>
               <a:t>Second level</a:t>
             </a:r>
           </a:p>
           <a:p>
             <a:pPr lvl="2"/>
             <a:r>
-              <a:rPr lang="en-US"/>
+              <a:rPr lang="en-US" smtClean="0"/>
               <a:t>Third level</a:t>
             </a:r>
           </a:p>
           <a:p>
             <a:pPr lvl="3"/>
             <a:r>
-              <a:rPr lang="en-US"/>
+              <a:rPr lang="en-US" smtClean="0"/>
               <a:t>Fourth level</a:t>
             </a:r>
           </a:p>
           <a:p>
             <a:pPr lvl="4"/>
             <a:r>
-              <a:rPr lang="en-US"/>
+              <a:rPr lang="en-US" smtClean="0"/>
               <a:t>Fifth level</a:t>
             </a:r>
+            <a:endParaRPr lang="en-US"/>
           </a:p>
         </p:txBody>
       </p:sp>
@@ -657,7 +647,7 @@
           <a:p>
             <a:fld id="{5BCAD085-E8A6-8845-BD4E-CB4CCA059FC4}" type="datetimeFigureOut">
               <a:rPr lang="en-US" smtClean="0"/>
-              <a:t>6/19/26</a:t>
+              <a:t>1/27/13</a:t>
             </a:fld>
             <a:endParaRPr lang="en-US"/>
           </a:p>
@@ -751,9 +741,10 @@
           <a:lstStyle/>
           <a:p>
             <a:r>
-              <a:rPr lang="en-US"/>
+              <a:rPr lang="en-US" smtClean="0"/>
               <a:t>Click to edit Master title style</a:t>
             </a:r>
+            <a:endParaRPr lang="en-US"/>
           </a:p>
         </p:txBody>
       </p:sp>
@@ -774,37 +765,38 @@
           <a:p>
             <a:pPr lvl="0"/>
             <a:r>
-              <a:rPr lang="en-US"/>
+              <a:rPr lang="en-US" smtClean="0"/>
               <a:t>Click to edit Master text styles</a:t>
             </a:r>
           </a:p>
           <a:p>
             <a:pPr lvl="1"/>
             <a:r>
-              <a:rPr lang="en-US"/>
+              <a:rPr lang="en-US" smtClean="0"/>
               <a:t>Second level</a:t>
             </a:r>
           </a:p>
           <a:p>
             <a:pPr lvl="2"/>
             <a:r>
-              <a:rPr lang="en-US"/>
+              <a:rPr lang="en-US" smtClean="0"/>
               <a:t>Third level</a:t>
             </a:r>
           </a:p>
           <a:p>
             <a:pPr lvl="3"/>
             <a:r>
-              <a:rPr lang="en-US"/>
+              <a:rPr lang="en-US" smtClean="0"/>
               <a:t>Fourth level</a:t>
             </a:r>
           </a:p>
           <a:p>
             <a:pPr lvl="4"/>
             <a:r>
-              <a:rPr lang="en-US"/>
+              <a:rPr lang="en-US" smtClean="0"/>
               <a:t>Fifth level</a:t>
             </a:r>
+            <a:endParaRPr lang="en-US"/>
           </a:p>
         </p:txBody>
       </p:sp>
@@ -825,7 +817,7 @@
           <a:p>
             <a:fld id="{5BCAD085-E8A6-8845-BD4E-CB4CCA059FC4}" type="datetimeFigureOut">
               <a:rPr lang="en-US" smtClean="0"/>
-              <a:t>6/19/26</a:t>
+              <a:t>1/27/13</a:t>
             </a:fld>
             <a:endParaRPr lang="en-US"/>
           </a:p>
@@ -928,9 +920,10 @@
           </a:lstStyle>
           <a:p>
             <a:r>
-              <a:rPr lang="en-US"/>
+              <a:rPr lang="en-US" smtClean="0"/>
               <a:t>Click to edit Master title style</a:t>
             </a:r>
+            <a:endParaRPr lang="en-US"/>
           </a:p>
         </p:txBody>
       </p:sp>
@@ -1047,7 +1040,7 @@
           <a:p>
             <a:pPr lvl="0"/>
             <a:r>
-              <a:rPr lang="en-US"/>
+              <a:rPr lang="en-US" smtClean="0"/>
               <a:t>Click to edit Master text styles</a:t>
             </a:r>
           </a:p>
@@ -1070,7 +1063,7 @@
           <a:p>
             <a:fld id="{5BCAD085-E8A6-8845-BD4E-CB4CCA059FC4}" type="datetimeFigureOut">
               <a:rPr lang="en-US" smtClean="0"/>
-              <a:t>6/19/26</a:t>
+              <a:t>1/27/13</a:t>
             </a:fld>
             <a:endParaRPr lang="en-US"/>
           </a:p>
@@ -1164,9 +1157,10 @@
           <a:lstStyle/>
           <a:p>
             <a:r>
-              <a:rPr lang="en-US"/>
+              <a:rPr lang="en-US" smtClean="0"/>
               <a:t>Click to edit Master title style</a:t>
             </a:r>
+            <a:endParaRPr lang="en-US"/>
           </a:p>
         </p:txBody>
       </p:sp>
@@ -1220,37 +1214,38 @@
           <a:p>
             <a:pPr lvl="0"/>
             <a:r>
-              <a:rPr lang="en-US"/>
+              <a:rPr lang="en-US" smtClean="0"/>
               <a:t>Click to edit Master text styles</a:t>
             </a:r>
           </a:p>
           <a:p>
             <a:pPr lvl="1"/>
             <a:r>
-              <a:rPr lang="en-US"/>
+              <a:rPr lang="en-US" smtClean="0"/>
               <a:t>Second level</a:t>
             </a:r>
           </a:p>
           <a:p>
             <a:pPr lvl="2"/>
             <a:r>
-              <a:rPr lang="en-US"/>
+              <a:rPr lang="en-US" smtClean="0"/>
               <a:t>Third level</a:t>
             </a:r>
           </a:p>
           <a:p>
             <a:pPr lvl="3"/>
             <a:r>
-              <a:rPr lang="en-US"/>
+              <a:rPr lang="en-US" smtClean="0"/>
               <a:t>Fourth level</a:t>
             </a:r>
           </a:p>
           <a:p>
             <a:pPr lvl="4"/>
             <a:r>
-              <a:rPr lang="en-US"/>
+              <a:rPr lang="en-US" smtClean="0"/>
               <a:t>Fifth level</a:t>
             </a:r>
+            <a:endParaRPr lang="en-US"/>
           </a:p>
         </p:txBody>
       </p:sp>
@@ -1304,37 +1299,38 @@
           <a:p>
             <a:pPr lvl="0"/>
             <a:r>
-              <a:rPr lang="en-US"/>
+              <a:rPr lang="en-US" smtClean="0"/>
               <a:t>Click to edit Master text styles</a:t>
             </a:r>
           </a:p>
           <a:p>
             <a:pPr lvl="1"/>
             <a:r>
-              <a:rPr lang="en-US"/>
+              <a:rPr lang="en-US" smtClean="0"/>
               <a:t>Second level</a:t>
             </a:r>
           </a:p>
           <a:p>
             <a:pPr lvl="2"/>
             <a:r>
-              <a:rPr lang="en-US"/>
+              <a:rPr lang="en-US" smtClean="0"/>
               <a:t>Third level</a:t>
             </a:r>
           </a:p>
           <a:p>
             <a:pPr lvl="3"/>
             <a:r>
-              <a:rPr lang="en-US"/>
+              <a:rPr lang="en-US" smtClean="0"/>
               <a:t>Fourth level</a:t>
             </a:r>
           </a:p>
           <a:p>
             <a:pPr lvl="4"/>
             <a:r>
-              <a:rPr lang="en-US"/>
+              <a:rPr lang="en-US" smtClean="0"/>
               <a:t>Fifth level</a:t>
             </a:r>
+            <a:endParaRPr lang="en-US"/>
           </a:p>
         </p:txBody>
       </p:sp>
@@ -1355,7 +1351,7 @@
           <a:p>
             <a:fld id="{5BCAD085-E8A6-8845-BD4E-CB4CCA059FC4}" type="datetimeFigureOut">
               <a:rPr lang="en-US" smtClean="0"/>
-              <a:t>6/19/26</a:t>
+              <a:t>1/27/13</a:t>
             </a:fld>
             <a:endParaRPr lang="en-US"/>
           </a:p>
@@ -1453,9 +1449,10 @@
           </a:lstStyle>
           <a:p>
             <a:r>
-              <a:rPr lang="en-US"/>
+              <a:rPr lang="en-US" smtClean="0"/>
               <a:t>Click to edit Master title style</a:t>
             </a:r>
+            <a:endParaRPr lang="en-US"/>
           </a:p>
         </p:txBody>
       </p:sp>
@@ -1518,7 +1515,7 @@
           <a:p>
             <a:pPr lvl="0"/>
             <a:r>
-              <a:rPr lang="en-US"/>
+              <a:rPr lang="en-US" smtClean="0"/>
               <a:t>Click to edit Master text styles</a:t>
             </a:r>
           </a:p>
@@ -1574,37 +1571,38 @@
           <a:p>
             <a:pPr lvl="0"/>
             <a:r>
-              <a:rPr lang="en-US"/>
+              <a:rPr lang="en-US" smtClean="0"/>
               <a:t>Click to edit Master text styles</a:t>
             </a:r>
           </a:p>
           <a:p>
             <a:pPr lvl="1"/>
             <a:r>
-              <a:rPr lang="en-US"/>
+              <a:rPr lang="en-US" smtClean="0"/>
               <a:t>Second level</a:t>
             </a:r>
           </a:p>
           <a:p>
             <a:pPr lvl="2"/>
             <a:r>
-              <a:rPr lang="en-US"/>
+              <a:rPr lang="en-US" smtClean="0"/>
               <a:t>Third level</a:t>
             </a:r>
           </a:p>
           <a:p>
             <a:pPr lvl="3"/>
             <a:r>
-              <a:rPr lang="en-US"/>
+              <a:rPr lang="en-US" smtClean="0"/>
               <a:t>Fourth level</a:t>
             </a:r>
           </a:p>
           <a:p>
             <a:pPr lvl="4"/>
             <a:r>
-              <a:rPr lang="en-US"/>
+              <a:rPr lang="en-US" smtClean="0"/>
               <a:t>Fifth level</a:t>
             </a:r>
+            <a:endParaRPr lang="en-US"/>
           </a:p>
         </p:txBody>
       </p:sp>
@@ -1667,7 +1665,7 @@
           <a:p>
             <a:pPr lvl="0"/>
             <a:r>
-              <a:rPr lang="en-US"/>
+              <a:rPr lang="en-US" smtClean="0"/>
               <a:t>Click to edit Master text styles</a:t>
             </a:r>
           </a:p>
@@ -1723,37 +1721,38 @@
           <a:p>
             <a:pPr lvl="0"/>
             <a:r>
-              <a:rPr lang="en-US"/>
+              <a:rPr lang="en-US" smtClean="0"/>
               <a:t>Click to edit Master text styles</a:t>
             </a:r>
           </a:p>
           <a:p>
             <a:pPr lvl="1"/>
             <a:r>
-              <a:rPr lang="en-US"/>
+              <a:rPr lang="en-US" smtClean="0"/>
               <a:t>Second level</a:t>
             </a:r>
           </a:p>
           <a:p>
             <a:pPr lvl="2"/>
             <a:r>
-              <a:rPr lang="en-US"/>
+              <a:rPr lang="en-US" smtClean="0"/>
               <a:t>Third level</a:t>
             </a:r>
           </a:p>
           <a:p>
             <a:pPr lvl="3"/>
             <a:r>
-              <a:rPr lang="en-US"/>
+              <a:rPr lang="en-US" smtClean="0"/>
               <a:t>Fourth level</a:t>
             </a:r>
           </a:p>
           <a:p>
             <a:pPr lvl="4"/>
             <a:r>
-              <a:rPr lang="en-US"/>
+              <a:rPr lang="en-US" smtClean="0"/>
               <a:t>Fifth level</a:t>
             </a:r>
+            <a:endParaRPr lang="en-US"/>
           </a:p>
         </p:txBody>
       </p:sp>
@@ -1774,7 +1773,7 @@
           <a:p>
             <a:fld id="{5BCAD085-E8A6-8845-BD4E-CB4CCA059FC4}" type="datetimeFigureOut">
               <a:rPr lang="en-US" smtClean="0"/>
-              <a:t>6/19/26</a:t>
+              <a:t>1/27/13</a:t>
             </a:fld>
             <a:endParaRPr lang="en-US"/>
           </a:p>
@@ -1868,9 +1867,10 @@
           <a:lstStyle/>
           <a:p>
             <a:r>
-              <a:rPr lang="en-US"/>
+              <a:rPr lang="en-US" smtClean="0"/>
               <a:t>Click to edit Master title style</a:t>
             </a:r>
+            <a:endParaRPr lang="en-US"/>
           </a:p>
         </p:txBody>
       </p:sp>
@@ -1891,7 +1891,7 @@
           <a:p>
             <a:fld id="{5BCAD085-E8A6-8845-BD4E-CB4CCA059FC4}" type="datetimeFigureOut">
               <a:rPr lang="en-US" smtClean="0"/>
-              <a:t>6/19/26</a:t>
+              <a:t>1/27/13</a:t>
             </a:fld>
             <a:endParaRPr lang="en-US"/>
           </a:p>
@@ -1986,7 +1986,7 @@
           <a:p>
             <a:fld id="{5BCAD085-E8A6-8845-BD4E-CB4CCA059FC4}" type="datetimeFigureOut">
               <a:rPr lang="en-US" smtClean="0"/>
-              <a:t>6/19/26</a:t>
+              <a:t>1/27/13</a:t>
             </a:fld>
             <a:endParaRPr lang="en-US"/>
           </a:p>
@@ -2089,9 +2089,10 @@
           </a:lstStyle>
           <a:p>
             <a:r>
-              <a:rPr lang="en-US"/>
+              <a:rPr lang="en-US" smtClean="0"/>
               <a:t>Click to edit Master title style</a:t>
             </a:r>
+            <a:endParaRPr lang="en-US"/>
           </a:p>
         </p:txBody>
       </p:sp>
@@ -2145,37 +2146,38 @@
           <a:p>
             <a:pPr lvl="0"/>
             <a:r>
-              <a:rPr lang="en-US"/>
+              <a:rPr lang="en-US" smtClean="0"/>
               <a:t>Click to edit Master text styles</a:t>
             </a:r>
           </a:p>
           <a:p>
             <a:pPr lvl="1"/>
             <a:r>
-              <a:rPr lang="en-US"/>
+              <a:rPr lang="en-US" smtClean="0"/>
               <a:t>Second level</a:t>
             </a:r>
           </a:p>
           <a:p>
             <a:pPr lvl="2"/>
             <a:r>
-              <a:rPr lang="en-US"/>
+              <a:rPr lang="en-US" smtClean="0"/>
               <a:t>Third level</a:t>
             </a:r>
           </a:p>
           <a:p>
             <a:pPr lvl="3"/>
             <a:r>
-              <a:rPr lang="en-US"/>
+              <a:rPr lang="en-US" smtClean="0"/>
               <a:t>Fourth level</a:t>
             </a:r>
           </a:p>
           <a:p>
             <a:pPr lvl="4"/>
             <a:r>
-              <a:rPr lang="en-US"/>
+              <a:rPr lang="en-US" smtClean="0"/>
               <a:t>Fifth level</a:t>
             </a:r>
+            <a:endParaRPr lang="en-US"/>
           </a:p>
         </p:txBody>
       </p:sp>
@@ -2238,7 +2240,7 @@
           <a:p>
             <a:pPr lvl="0"/>
             <a:r>
-              <a:rPr lang="en-US"/>
+              <a:rPr lang="en-US" smtClean="0"/>
               <a:t>Click to edit Master text styles</a:t>
             </a:r>
           </a:p>
@@ -2261,7 +2263,7 @@
           <a:p>
             <a:fld id="{5BCAD085-E8A6-8845-BD4E-CB4CCA059FC4}" type="datetimeFigureOut">
               <a:rPr lang="en-US" smtClean="0"/>
-              <a:t>6/19/26</a:t>
+              <a:t>1/27/13</a:t>
             </a:fld>
             <a:endParaRPr lang="en-US"/>
           </a:p>
@@ -2364,9 +2366,10 @@
           </a:lstStyle>
           <a:p>
             <a:r>
-              <a:rPr lang="en-US"/>
+              <a:rPr lang="en-US" smtClean="0"/>
               <a:t>Click to edit Master title style</a:t>
             </a:r>
+            <a:endParaRPr lang="en-US"/>
           </a:p>
         </p:txBody>
       </p:sp>
@@ -2490,7 +2493,7 @@
           <a:p>
             <a:pPr lvl="0"/>
             <a:r>
-              <a:rPr lang="en-US"/>
+              <a:rPr lang="en-US" smtClean="0"/>
               <a:t>Click to edit Master text styles</a:t>
             </a:r>
           </a:p>
@@ -2513,7 +2516,7 @@
           <a:p>
             <a:fld id="{5BCAD085-E8A6-8845-BD4E-CB4CCA059FC4}" type="datetimeFigureOut">
               <a:rPr lang="en-US" smtClean="0"/>
-              <a:t>6/19/26</a:t>
+              <a:t>1/27/13</a:t>
             </a:fld>
             <a:endParaRPr lang="en-US"/>
           </a:p>
@@ -2622,9 +2625,10 @@
           <a:lstStyle/>
           <a:p>
             <a:r>
-              <a:rPr lang="en-US"/>
+              <a:rPr lang="en-US" smtClean="0"/>
               <a:t>Click to edit Master title style</a:t>
             </a:r>
+            <a:endParaRPr lang="en-US"/>
           </a:p>
         </p:txBody>
       </p:sp>
@@ -2655,37 +2659,38 @@
           <a:p>
             <a:pPr lvl="0"/>
             <a:r>
-              <a:rPr lang="en-US"/>
+              <a:rPr lang="en-US" smtClean="0"/>
               <a:t>Click to edit Master text styles</a:t>
             </a:r>
           </a:p>
           <a:p>
             <a:pPr lvl="1"/>
             <a:r>
-              <a:rPr lang="en-US"/>
+              <a:rPr lang="en-US" smtClean="0"/>
               <a:t>Second level</a:t>
             </a:r>
           </a:p>
           <a:p>
             <a:pPr lvl="2"/>
             <a:r>
-              <a:rPr lang="en-US"/>
+              <a:rPr lang="en-US" smtClean="0"/>
               <a:t>Third level</a:t>
             </a:r>
           </a:p>
           <a:p>
             <a:pPr lvl="3"/>
             <a:r>
-              <a:rPr lang="en-US"/>
+              <a:rPr lang="en-US" smtClean="0"/>
               <a:t>Fourth level</a:t>
             </a:r>
           </a:p>
           <a:p>
             <a:pPr lvl="4"/>
             <a:r>
-              <a:rPr lang="en-US"/>
+              <a:rPr lang="en-US" smtClean="0"/>
               <a:t>Fifth level</a:t>
             </a:r>
+            <a:endParaRPr lang="en-US"/>
           </a:p>
         </p:txBody>
       </p:sp>
@@ -2724,7 +2729,7 @@
           <a:p>
             <a:fld id="{5BCAD085-E8A6-8845-BD4E-CB4CCA059FC4}" type="datetimeFigureOut">
               <a:rPr lang="en-US" smtClean="0"/>
-              <a:t>6/19/26</a:t>
+              <a:t>1/27/13</a:t>
             </a:fld>
             <a:endParaRPr lang="en-US"/>
           </a:p>
@@ -3083,7 +3088,7 @@
 </file>
 
 <file path=ppt/slides/slide1.xml><?xml version="1.0" encoding="utf-8"?>
-<p:sld xmlns:a="http://schemas.openxmlformats.org/drawingml/2006/main" xmlns:r="http://schemas.openxmlformats.org/officeDocument/2006/relationships" xmlns:p="http://schemas.openxmlformats.org/presentationml/2006/main">
+<p:sld xmlns:a="http://schemas.openxmlformats.org/drawingml/2006/main" xmlns:p="http://schemas.openxmlformats.org/presentationml/2006/main" xmlns:r="http://schemas.openxmlformats.org/officeDocument/2006/relationships">
   <p:cSld>
     <p:bg>
       <p:bgPr>
@@ -3099,14 +3104,7 @@
         <p:cNvGrpSpPr/>
         <p:nvPr/>
       </p:nvGrpSpPr>
-      <p:grpSpPr>
-        <a:xfrm>
-          <a:off x="0" y="0"/>
-          <a:ext cx="0" cy="0"/>
-          <a:chOff x="0" y="0"/>
-          <a:chExt cx="0" cy="0"/>
-        </a:xfrm>
-      </p:grpSpPr>
+      <p:grpSpPr/>
       <p:sp>
         <p:nvSpPr>
           <p:cNvPr id="2" name="Rectangle 1"/>
@@ -3147,7 +3145,6 @@
           <a:lstStyle/>
           <a:p>
             <a:pPr algn="ctr"/>
-            <a:endParaRPr/>
           </a:p>
         </p:txBody>
       </p:sp>
@@ -3265,7 +3262,7 @@
         <p:spPr>
           <a:xfrm>
             <a:off x="411480" y="2606040"/>
-            <a:ext cx="5486400" cy="323165"/>
+            <a:ext cx="5486400" cy="347472"/>
           </a:xfrm>
           <a:prstGeom prst="rect">
             <a:avLst/>
@@ -3280,13 +3277,13 @@
           <a:p>
             <a:pPr algn="l"/>
             <a:r>
-              <a:rPr sz="1500" b="0" i="0" dirty="0">
+              <a:rPr sz="1500" b="0" i="0">
                 <a:solidFill>
                   <a:srgbClr val="2C3E50"/>
                 </a:solidFill>
                 <a:latin typeface="Calibri"/>
               </a:rPr>
-              <a:t>  Joyce Yeo </a:t>
+              <a:t>  Joyce Yeo  —  SNAIC Learner</a:t>
             </a:r>
           </a:p>
         </p:txBody>
@@ -3300,7 +3297,7 @@
         <p:spPr>
           <a:xfrm>
             <a:off x="411480" y="2971800"/>
-            <a:ext cx="5486400" cy="323165"/>
+            <a:ext cx="5486400" cy="347472"/>
           </a:xfrm>
           <a:prstGeom prst="rect">
             <a:avLst/>
@@ -3315,38 +3312,14 @@
           <a:p>
             <a:pPr algn="l"/>
             <a:r>
-              <a:rPr sz="1500" b="0" i="0" dirty="0">
+              <a:rPr sz="1500" b="0" i="0">
                 <a:solidFill>
                   <a:srgbClr val="2C3E50"/>
                 </a:solidFill>
                 <a:latin typeface="Calibri"/>
               </a:rPr>
-              <a:t>  </a:t>
-            </a:r>
-            <a:r>
-              <a:rPr sz="1500" b="0" i="0" dirty="0" err="1">
-                <a:solidFill>
-                  <a:srgbClr val="2C3E50"/>
-                </a:solidFill>
-                <a:latin typeface="Calibri"/>
-              </a:rPr>
-              <a:t>KhoonSen</a:t>
-            </a:r>
-            <a:r>
-              <a:rPr lang="en-US" sz="1500" b="0" i="0" dirty="0" err="1">
-                <a:solidFill>
-                  <a:srgbClr val="2C3E50"/>
-                </a:solidFill>
-                <a:latin typeface="Calibri"/>
-              </a:rPr>
-              <a:t>g</a:t>
-            </a:r>
-            <a:endParaRPr sz="1500" b="0" i="0" dirty="0">
-              <a:solidFill>
-                <a:srgbClr val="2C3E50"/>
-              </a:solidFill>
-              <a:latin typeface="Calibri"/>
-            </a:endParaRPr>
+              <a:t>  KhoonSeng  —  SNAIC Learner</a:t>
+            </a:r>
           </a:p>
         </p:txBody>
       </p:sp>
@@ -3359,7 +3332,7 @@
         <p:spPr>
           <a:xfrm>
             <a:off x="411480" y="3337560"/>
-            <a:ext cx="5486400" cy="323165"/>
+            <a:ext cx="5486400" cy="347472"/>
           </a:xfrm>
           <a:prstGeom prst="rect">
             <a:avLst/>
@@ -3374,29 +3347,14 @@
           <a:p>
             <a:pPr algn="l"/>
             <a:r>
-              <a:rPr sz="1500" b="0" i="0" dirty="0">
+              <a:rPr sz="1500" b="0" i="0">
                 <a:solidFill>
                   <a:srgbClr val="2C3E50"/>
                 </a:solidFill>
                 <a:latin typeface="Calibri"/>
               </a:rPr>
-              <a:t>  </a:t>
-            </a:r>
-            <a:r>
-              <a:rPr lang="en-US" sz="1500" b="0" i="0" dirty="0">
-                <a:solidFill>
-                  <a:srgbClr val="2C3E50"/>
-                </a:solidFill>
-                <a:latin typeface="Calibri"/>
-              </a:rPr>
-              <a:t>Lai Kin Wah</a:t>
-            </a:r>
-            <a:endParaRPr sz="1500" b="0" i="0" dirty="0">
-              <a:solidFill>
-                <a:srgbClr val="2C3E50"/>
-              </a:solidFill>
-              <a:latin typeface="Calibri"/>
-            </a:endParaRPr>
+              <a:t>  Lai Kin Wah  —  SNAIC Learner</a:t>
+            </a:r>
           </a:p>
         </p:txBody>
       </p:sp>
@@ -3479,7 +3437,7 @@
 </file>
 
 <file path=ppt/slides/slide10.xml><?xml version="1.0" encoding="utf-8"?>
-<p:sld xmlns:a="http://schemas.openxmlformats.org/drawingml/2006/main" xmlns:r="http://schemas.openxmlformats.org/officeDocument/2006/relationships" xmlns:p="http://schemas.openxmlformats.org/presentationml/2006/main">
+<p:sld xmlns:a="http://schemas.openxmlformats.org/drawingml/2006/main" xmlns:p="http://schemas.openxmlformats.org/presentationml/2006/main" xmlns:r="http://schemas.openxmlformats.org/officeDocument/2006/relationships">
   <p:cSld>
     <p:bg>
       <p:bgPr>
@@ -3495,14 +3453,7 @@
         <p:cNvGrpSpPr/>
         <p:nvPr/>
       </p:nvGrpSpPr>
-      <p:grpSpPr>
-        <a:xfrm>
-          <a:off x="0" y="0"/>
-          <a:ext cx="0" cy="0"/>
-          <a:chOff x="0" y="0"/>
-          <a:chExt cx="0" cy="0"/>
-        </a:xfrm>
-      </p:grpSpPr>
+      <p:grpSpPr/>
       <p:sp>
         <p:nvSpPr>
           <p:cNvPr id="2" name="Rectangle 1"/>
@@ -3543,7 +3494,6 @@
           <a:lstStyle/>
           <a:p>
             <a:pPr algn="ctr"/>
-            <a:endParaRPr/>
           </a:p>
         </p:txBody>
       </p:sp>
@@ -3623,13 +3573,7 @@
           <p:cNvGraphicFramePr>
             <a:graphicFrameLocks noGrp="1"/>
           </p:cNvGraphicFramePr>
-          <p:nvPr>
-            <p:extLst>
-              <p:ext uri="{D42A27DB-BD31-4B8C-83A1-F6EECF244321}">
-                <p14:modId xmlns:p14="http://schemas.microsoft.com/office/powerpoint/2010/main" val="4288233781"/>
-              </p:ext>
-            </p:extLst>
-          </p:nvPr>
+          <p:nvPr/>
         </p:nvGraphicFramePr>
         <p:xfrm>
           <a:off x="411480" y="1042416"/>
@@ -3642,27 +3586,9 @@
                 <a:tableStyleId>{5C22544A-7EE6-4342-B048-85BDC9FD1C3A}</a:tableStyleId>
               </a:tblPr>
               <a:tblGrid>
-                <a:gridCol w="4114800">
-                  <a:extLst>
-                    <a:ext uri="{9D8B030D-6E8A-4147-A177-3AD203B41FA5}">
-                      <a16:colId xmlns:a16="http://schemas.microsoft.com/office/drawing/2014/main" val="20000"/>
-                    </a:ext>
-                  </a:extLst>
-                </a:gridCol>
-                <a:gridCol w="3200400">
-                  <a:extLst>
-                    <a:ext uri="{9D8B030D-6E8A-4147-A177-3AD203B41FA5}">
-                      <a16:colId xmlns:a16="http://schemas.microsoft.com/office/drawing/2014/main" val="20001"/>
-                    </a:ext>
-                  </a:extLst>
-                </a:gridCol>
-                <a:gridCol w="3200400">
-                  <a:extLst>
-                    <a:ext uri="{9D8B030D-6E8A-4147-A177-3AD203B41FA5}">
-                      <a16:colId xmlns:a16="http://schemas.microsoft.com/office/drawing/2014/main" val="20002"/>
-                    </a:ext>
-                  </a:extLst>
-                </a:gridCol>
+                <a:gridCol w="4114800"/>
+                <a:gridCol w="3200400"/>
+                <a:gridCol w="3200400"/>
               </a:tblGrid>
               <a:tr h="310896">
                 <a:tc>
@@ -3734,11 +3660,6 @@
                     </a:solidFill>
                   </a:tcPr>
                 </a:tc>
-                <a:extLst>
-                  <a:ext uri="{0D108BD9-81ED-4DB2-BD59-A6C34878D82A}">
-                    <a16:rowId xmlns:a16="http://schemas.microsoft.com/office/drawing/2014/main" val="10000"/>
-                  </a:ext>
-                </a:extLst>
               </a:tr>
               <a:tr h="310896">
                 <a:tc>
@@ -3810,11 +3731,6 @@
                     </a:solidFill>
                   </a:tcPr>
                 </a:tc>
-                <a:extLst>
-                  <a:ext uri="{0D108BD9-81ED-4DB2-BD59-A6C34878D82A}">
-                    <a16:rowId xmlns:a16="http://schemas.microsoft.com/office/drawing/2014/main" val="10001"/>
-                  </a:ext>
-                </a:extLst>
               </a:tr>
               <a:tr h="310896">
                 <a:tc>
@@ -3870,20 +3786,14 @@
                     <a:p>
                       <a:pPr algn="ctr"/>
                       <a:r>
-                        <a:rPr lang="en-US" sz="1000" dirty="0">
+                        <a:rPr sz="1000">
                           <a:solidFill>
                             <a:srgbClr val="2C3E50"/>
                           </a:solidFill>
-                          <a:latin typeface="+mn-lt"/>
+                          <a:latin typeface="Calibri"/>
                         </a:rPr>
                         <a:t>Lai Kin Wah</a:t>
                       </a:r>
-                      <a:endParaRPr sz="1000" dirty="0">
-                        <a:solidFill>
-                          <a:srgbClr val="2C3E50"/>
-                        </a:solidFill>
-                        <a:latin typeface="Calibri"/>
-                      </a:endParaRPr>
                     </a:p>
                   </a:txBody>
                   <a:tcPr>
@@ -3892,11 +3802,6 @@
                     </a:solidFill>
                   </a:tcPr>
                 </a:tc>
-                <a:extLst>
-                  <a:ext uri="{0D108BD9-81ED-4DB2-BD59-A6C34878D82A}">
-                    <a16:rowId xmlns:a16="http://schemas.microsoft.com/office/drawing/2014/main" val="10002"/>
-                  </a:ext>
-                </a:extLst>
               </a:tr>
               <a:tr h="310896">
                 <a:tc>
@@ -3929,7 +3834,7 @@
                     <a:p>
                       <a:pPr algn="ctr"/>
                       <a:r>
-                        <a:rPr lang="en-US" sz="1000" dirty="0">
+                        <a:rPr sz="1000">
                           <a:solidFill>
                             <a:srgbClr val="2C3E50"/>
                           </a:solidFill>
@@ -3937,12 +3842,6 @@
                         </a:rPr>
                         <a:t>Lai Kin Wah</a:t>
                       </a:r>
-                      <a:endParaRPr sz="1000" dirty="0">
-                        <a:solidFill>
-                          <a:srgbClr val="2C3E50"/>
-                        </a:solidFill>
-                        <a:latin typeface="Calibri"/>
-                      </a:endParaRPr>
                     </a:p>
                   </a:txBody>
                   <a:tcPr>
@@ -3974,11 +3873,6 @@
                     </a:solidFill>
                   </a:tcPr>
                 </a:tc>
-                <a:extLst>
-                  <a:ext uri="{0D108BD9-81ED-4DB2-BD59-A6C34878D82A}">
-                    <a16:rowId xmlns:a16="http://schemas.microsoft.com/office/drawing/2014/main" val="10003"/>
-                  </a:ext>
-                </a:extLst>
               </a:tr>
               <a:tr h="310896">
                 <a:tc>
@@ -4050,11 +3944,6 @@
                     </a:solidFill>
                   </a:tcPr>
                 </a:tc>
-                <a:extLst>
-                  <a:ext uri="{0D108BD9-81ED-4DB2-BD59-A6C34878D82A}">
-                    <a16:rowId xmlns:a16="http://schemas.microsoft.com/office/drawing/2014/main" val="10004"/>
-                  </a:ext>
-                </a:extLst>
               </a:tr>
               <a:tr h="310896">
                 <a:tc>
@@ -4087,7 +3976,7 @@
                     <a:p>
                       <a:pPr algn="ctr"/>
                       <a:r>
-                        <a:rPr sz="1000" dirty="0">
+                        <a:rPr sz="1000">
                           <a:solidFill>
                             <a:srgbClr val="2C3E50"/>
                           </a:solidFill>
@@ -4110,20 +3999,14 @@
                     <a:p>
                       <a:pPr algn="ctr"/>
                       <a:r>
-                        <a:rPr lang="en-US" sz="1000" dirty="0">
+                        <a:rPr sz="1000">
                           <a:solidFill>
                             <a:srgbClr val="2C3E50"/>
                           </a:solidFill>
-                          <a:latin typeface="+mn-lt"/>
+                          <a:latin typeface="Calibri"/>
                         </a:rPr>
                         <a:t>Lai Kin Wah</a:t>
                       </a:r>
-                      <a:endParaRPr sz="1000" dirty="0">
-                        <a:solidFill>
-                          <a:srgbClr val="2C3E50"/>
-                        </a:solidFill>
-                        <a:latin typeface="Calibri"/>
-                      </a:endParaRPr>
                     </a:p>
                   </a:txBody>
                   <a:tcPr>
@@ -4132,11 +4015,6 @@
                     </a:solidFill>
                   </a:tcPr>
                 </a:tc>
-                <a:extLst>
-                  <a:ext uri="{0D108BD9-81ED-4DB2-BD59-A6C34878D82A}">
-                    <a16:rowId xmlns:a16="http://schemas.microsoft.com/office/drawing/2014/main" val="10005"/>
-                  </a:ext>
-                </a:extLst>
               </a:tr>
               <a:tr h="310896">
                 <a:tc>
@@ -4169,7 +4047,7 @@
                     <a:p>
                       <a:pPr algn="ctr"/>
                       <a:r>
-                        <a:rPr lang="en-US" sz="1000" dirty="0">
+                        <a:rPr sz="1000">
                           <a:solidFill>
                             <a:srgbClr val="2C3E50"/>
                           </a:solidFill>
@@ -4177,12 +4055,6 @@
                         </a:rPr>
                         <a:t>Lai Kin Wah</a:t>
                       </a:r>
-                      <a:endParaRPr sz="1000" dirty="0">
-                        <a:solidFill>
-                          <a:srgbClr val="2C3E50"/>
-                        </a:solidFill>
-                        <a:latin typeface="Calibri"/>
-                      </a:endParaRPr>
                     </a:p>
                   </a:txBody>
                   <a:tcPr>
@@ -4198,7 +4070,7 @@
                     <a:p>
                       <a:pPr algn="ctr"/>
                       <a:r>
-                        <a:rPr sz="1000" dirty="0" err="1">
+                        <a:rPr sz="1000">
                           <a:solidFill>
                             <a:srgbClr val="2C3E50"/>
                           </a:solidFill>
@@ -4206,12 +4078,6 @@
                         </a:rPr>
                         <a:t>KhoonSeng</a:t>
                       </a:r>
-                      <a:endParaRPr sz="1000" dirty="0">
-                        <a:solidFill>
-                          <a:srgbClr val="2C3E50"/>
-                        </a:solidFill>
-                        <a:latin typeface="Calibri"/>
-                      </a:endParaRPr>
                     </a:p>
                   </a:txBody>
                   <a:tcPr>
@@ -4220,16 +4086,151 @@
                     </a:solidFill>
                   </a:tcPr>
                 </a:tc>
-                <a:extLst>
-                  <a:ext uri="{0D108BD9-81ED-4DB2-BD59-A6C34878D82A}">
-                    <a16:rowId xmlns:a16="http://schemas.microsoft.com/office/drawing/2014/main" val="10006"/>
-                  </a:ext>
-                </a:extLst>
               </a:tr>
             </a:tbl>
           </a:graphicData>
         </a:graphic>
       </p:graphicFrame>
+      <p:sp>
+        <p:nvSpPr>
+          <p:cNvPr id="6" name="TextBox 5"/>
+          <p:cNvSpPr txBox="1"/>
+          <p:nvPr/>
+        </p:nvSpPr>
+        <p:spPr>
+          <a:xfrm>
+            <a:off x="411480" y="3602736"/>
+            <a:ext cx="11368735" cy="320040"/>
+          </a:xfrm>
+          <a:prstGeom prst="rect">
+            <a:avLst/>
+          </a:prstGeom>
+          <a:noFill/>
+        </p:spPr>
+        <p:txBody>
+          <a:bodyPr wrap="square">
+            <a:spAutoFit/>
+          </a:bodyPr>
+          <a:lstStyle/>
+          <a:p>
+            <a:pPr algn="l"/>
+            <a:r>
+              <a:rPr sz="1100" b="1" i="0">
+                <a:solidFill>
+                  <a:srgbClr val="7F8C8D"/>
+                </a:solidFill>
+                <a:latin typeface="Calibri"/>
+              </a:rPr>
+              <a:t>Balance check:</a:t>
+            </a:r>
+          </a:p>
+        </p:txBody>
+      </p:sp>
+      <p:sp>
+        <p:nvSpPr>
+          <p:cNvPr id="7" name="TextBox 6"/>
+          <p:cNvSpPr txBox="1"/>
+          <p:nvPr/>
+        </p:nvSpPr>
+        <p:spPr>
+          <a:xfrm>
+            <a:off x="411480" y="3922776"/>
+            <a:ext cx="11368735" cy="274320"/>
+          </a:xfrm>
+          <a:prstGeom prst="rect">
+            <a:avLst/>
+          </a:prstGeom>
+          <a:noFill/>
+        </p:spPr>
+        <p:txBody>
+          <a:bodyPr wrap="square">
+            <a:spAutoFit/>
+          </a:bodyPr>
+          <a:lstStyle/>
+          <a:p>
+            <a:pPr algn="l"/>
+            <a:r>
+              <a:rPr sz="1100" b="0" i="0">
+                <a:solidFill>
+                  <a:srgbClr val="2C3E50"/>
+                </a:solidFill>
+                <a:latin typeface="Calibri"/>
+              </a:rPr>
+              <a:t>Joyce Yeo:  2 areas as Primary  +  2 areas as Secondary</a:t>
+            </a:r>
+          </a:p>
+        </p:txBody>
+      </p:sp>
+      <p:sp>
+        <p:nvSpPr>
+          <p:cNvPr id="8" name="TextBox 7"/>
+          <p:cNvSpPr txBox="1"/>
+          <p:nvPr/>
+        </p:nvSpPr>
+        <p:spPr>
+          <a:xfrm>
+            <a:off x="411480" y="4197095"/>
+            <a:ext cx="11368735" cy="274320"/>
+          </a:xfrm>
+          <a:prstGeom prst="rect">
+            <a:avLst/>
+          </a:prstGeom>
+          <a:noFill/>
+        </p:spPr>
+        <p:txBody>
+          <a:bodyPr wrap="square">
+            <a:spAutoFit/>
+          </a:bodyPr>
+          <a:lstStyle/>
+          <a:p>
+            <a:pPr algn="l"/>
+            <a:r>
+              <a:rPr sz="1100" b="0" i="0">
+                <a:solidFill>
+                  <a:srgbClr val="2C3E50"/>
+                </a:solidFill>
+                <a:latin typeface="Calibri"/>
+              </a:rPr>
+              <a:t>KhoonSeng:  2 areas as Primary  +  2 areas as Secondary</a:t>
+            </a:r>
+          </a:p>
+        </p:txBody>
+      </p:sp>
+      <p:sp>
+        <p:nvSpPr>
+          <p:cNvPr id="9" name="TextBox 8"/>
+          <p:cNvSpPr txBox="1"/>
+          <p:nvPr/>
+        </p:nvSpPr>
+        <p:spPr>
+          <a:xfrm>
+            <a:off x="411480" y="4471416"/>
+            <a:ext cx="11368735" cy="274320"/>
+          </a:xfrm>
+          <a:prstGeom prst="rect">
+            <a:avLst/>
+          </a:prstGeom>
+          <a:noFill/>
+        </p:spPr>
+        <p:txBody>
+          <a:bodyPr wrap="square">
+            <a:spAutoFit/>
+          </a:bodyPr>
+          <a:lstStyle/>
+          <a:p>
+            <a:pPr algn="l"/>
+            <a:r>
+              <a:rPr sz="1100" b="0" i="0">
+                <a:solidFill>
+                  <a:srgbClr val="2C3E50"/>
+                </a:solidFill>
+                <a:latin typeface="Calibri"/>
+              </a:rPr>
+              <a:t>Lai Kin Wah:  2 areas as Primary  +  2 areas as Secondary</a:t>
+            </a:r>
+          </a:p>
+        </p:txBody>
+      </p:sp>
     </p:spTree>
   </p:cSld>
   <p:clrMapOvr>
@@ -4239,7 +4240,7 @@
 </file>
 
 <file path=ppt/slides/slide2.xml><?xml version="1.0" encoding="utf-8"?>
-<p:sld xmlns:a="http://schemas.openxmlformats.org/drawingml/2006/main" xmlns:r="http://schemas.openxmlformats.org/officeDocument/2006/relationships" xmlns:p="http://schemas.openxmlformats.org/presentationml/2006/main">
+<p:sld xmlns:a="http://schemas.openxmlformats.org/drawingml/2006/main" xmlns:p="http://schemas.openxmlformats.org/presentationml/2006/main" xmlns:r="http://schemas.openxmlformats.org/officeDocument/2006/relationships">
   <p:cSld>
     <p:bg>
       <p:bgPr>
@@ -4255,14 +4256,7 @@
         <p:cNvGrpSpPr/>
         <p:nvPr/>
       </p:nvGrpSpPr>
-      <p:grpSpPr>
-        <a:xfrm>
-          <a:off x="0" y="0"/>
-          <a:ext cx="0" cy="0"/>
-          <a:chOff x="0" y="0"/>
-          <a:chExt cx="0" cy="0"/>
-        </a:xfrm>
-      </p:grpSpPr>
+      <p:grpSpPr/>
       <p:sp>
         <p:nvSpPr>
           <p:cNvPr id="2" name="Rectangle 1"/>
@@ -4303,7 +4297,6 @@
           <a:lstStyle/>
           <a:p>
             <a:pPr algn="ctr"/>
-            <a:endParaRPr/>
           </a:p>
         </p:txBody>
       </p:sp>
@@ -4456,7 +4449,7 @@
                 </a:solidFill>
                 <a:latin typeface="Calibri"/>
               </a:rPr>
-              <a:t>◆  Threshold 0.61 selected to achieve ≥80% recall (FN cost ~$500+ &gt;&gt; FP cost ~$30)</a:t>
+              <a:t>◆  Threshold 0.61 = highest cut still holding ≥80% recall; FN far costlier than FP, and SMOTE lifts probabilities above 0.50</a:t>
             </a:r>
           </a:p>
           <a:p>
@@ -4486,7 +4479,7 @@
 </file>
 
 <file path=ppt/slides/slide3.xml><?xml version="1.0" encoding="utf-8"?>
-<p:sld xmlns:a="http://schemas.openxmlformats.org/drawingml/2006/main" xmlns:r="http://schemas.openxmlformats.org/officeDocument/2006/relationships" xmlns:p="http://schemas.openxmlformats.org/presentationml/2006/main">
+<p:sld xmlns:a="http://schemas.openxmlformats.org/drawingml/2006/main" xmlns:p="http://schemas.openxmlformats.org/presentationml/2006/main" xmlns:r="http://schemas.openxmlformats.org/officeDocument/2006/relationships">
   <p:cSld>
     <p:bg>
       <p:bgPr>
@@ -4502,14 +4495,7 @@
         <p:cNvGrpSpPr/>
         <p:nvPr/>
       </p:nvGrpSpPr>
-      <p:grpSpPr>
-        <a:xfrm>
-          <a:off x="0" y="0"/>
-          <a:ext cx="0" cy="0"/>
-          <a:chOff x="0" y="0"/>
-          <a:chExt cx="0" cy="0"/>
-        </a:xfrm>
-      </p:grpSpPr>
+      <p:grpSpPr/>
       <p:sp>
         <p:nvSpPr>
           <p:cNvPr id="2" name="Rectangle 1"/>
@@ -4550,7 +4536,6 @@
           <a:lstStyle/>
           <a:p>
             <a:pPr algn="ctr"/>
-            <a:endParaRPr/>
           </a:p>
         </p:txBody>
       </p:sp>
@@ -4811,7 +4796,7 @@
 </file>
 
 <file path=ppt/slides/slide4.xml><?xml version="1.0" encoding="utf-8"?>
-<p:sld xmlns:a="http://schemas.openxmlformats.org/drawingml/2006/main" xmlns:r="http://schemas.openxmlformats.org/officeDocument/2006/relationships" xmlns:p="http://schemas.openxmlformats.org/presentationml/2006/main">
+<p:sld xmlns:a="http://schemas.openxmlformats.org/drawingml/2006/main" xmlns:p="http://schemas.openxmlformats.org/presentationml/2006/main" xmlns:r="http://schemas.openxmlformats.org/officeDocument/2006/relationships">
   <p:cSld>
     <p:bg>
       <p:bgPr>
@@ -4827,14 +4812,7 @@
         <p:cNvGrpSpPr/>
         <p:nvPr/>
       </p:nvGrpSpPr>
-      <p:grpSpPr>
-        <a:xfrm>
-          <a:off x="0" y="0"/>
-          <a:ext cx="0" cy="0"/>
-          <a:chOff x="0" y="0"/>
-          <a:chExt cx="0" cy="0"/>
-        </a:xfrm>
-      </p:grpSpPr>
+      <p:grpSpPr/>
       <p:sp>
         <p:nvSpPr>
           <p:cNvPr id="2" name="Rectangle 1"/>
@@ -4875,7 +4853,6 @@
           <a:lstStyle/>
           <a:p>
             <a:pPr algn="ctr"/>
-            <a:endParaRPr/>
           </a:p>
         </p:txBody>
       </p:sp>
@@ -4989,7 +4966,6 @@
           <a:lstStyle/>
           <a:p>
             <a:pPr algn="ctr"/>
-            <a:endParaRPr/>
           </a:p>
         </p:txBody>
       </p:sp>
@@ -5259,7 +5235,7 @@
 </file>
 
 <file path=ppt/slides/slide5.xml><?xml version="1.0" encoding="utf-8"?>
-<p:sld xmlns:a="http://schemas.openxmlformats.org/drawingml/2006/main" xmlns:r="http://schemas.openxmlformats.org/officeDocument/2006/relationships" xmlns:p="http://schemas.openxmlformats.org/presentationml/2006/main">
+<p:sld xmlns:a="http://schemas.openxmlformats.org/drawingml/2006/main" xmlns:p="http://schemas.openxmlformats.org/presentationml/2006/main" xmlns:r="http://schemas.openxmlformats.org/officeDocument/2006/relationships">
   <p:cSld>
     <p:bg>
       <p:bgPr>
@@ -5275,14 +5251,7 @@
         <p:cNvGrpSpPr/>
         <p:nvPr/>
       </p:nvGrpSpPr>
-      <p:grpSpPr>
-        <a:xfrm>
-          <a:off x="0" y="0"/>
-          <a:ext cx="0" cy="0"/>
-          <a:chOff x="0" y="0"/>
-          <a:chExt cx="0" cy="0"/>
-        </a:xfrm>
-      </p:grpSpPr>
+      <p:grpSpPr/>
       <p:sp>
         <p:nvSpPr>
           <p:cNvPr id="2" name="Rectangle 1"/>
@@ -5323,7 +5292,6 @@
           <a:lstStyle/>
           <a:p>
             <a:pPr algn="ctr"/>
-            <a:endParaRPr/>
           </a:p>
         </p:txBody>
       </p:sp>
@@ -5416,27 +5384,9 @@
                 <a:tableStyleId>{5C22544A-7EE6-4342-B048-85BDC9FD1C3A}</a:tableStyleId>
               </a:tblPr>
               <a:tblGrid>
-                <a:gridCol w="3200400">
-                  <a:extLst>
-                    <a:ext uri="{9D8B030D-6E8A-4147-A177-3AD203B41FA5}">
-                      <a16:colId xmlns:a16="http://schemas.microsoft.com/office/drawing/2014/main" val="20000"/>
-                    </a:ext>
-                  </a:extLst>
-                </a:gridCol>
-                <a:gridCol w="2103120">
-                  <a:extLst>
-                    <a:ext uri="{9D8B030D-6E8A-4147-A177-3AD203B41FA5}">
-                      <a16:colId xmlns:a16="http://schemas.microsoft.com/office/drawing/2014/main" val="20001"/>
-                    </a:ext>
-                  </a:extLst>
-                </a:gridCol>
-                <a:gridCol w="2103120">
-                  <a:extLst>
-                    <a:ext uri="{9D8B030D-6E8A-4147-A177-3AD203B41FA5}">
-                      <a16:colId xmlns:a16="http://schemas.microsoft.com/office/drawing/2014/main" val="20002"/>
-                    </a:ext>
-                  </a:extLst>
-                </a:gridCol>
+                <a:gridCol w="3200400"/>
+                <a:gridCol w="2103120"/>
+                <a:gridCol w="2103120"/>
               </a:tblGrid>
               <a:tr h="310896">
                 <a:tc>
@@ -5508,11 +5458,6 @@
                     </a:solidFill>
                   </a:tcPr>
                 </a:tc>
-                <a:extLst>
-                  <a:ext uri="{0D108BD9-81ED-4DB2-BD59-A6C34878D82A}">
-                    <a16:rowId xmlns:a16="http://schemas.microsoft.com/office/drawing/2014/main" val="10000"/>
-                  </a:ext>
-                </a:extLst>
               </a:tr>
               <a:tr h="310896">
                 <a:tc>
@@ -5584,11 +5529,6 @@
                     </a:solidFill>
                   </a:tcPr>
                 </a:tc>
-                <a:extLst>
-                  <a:ext uri="{0D108BD9-81ED-4DB2-BD59-A6C34878D82A}">
-                    <a16:rowId xmlns:a16="http://schemas.microsoft.com/office/drawing/2014/main" val="10001"/>
-                  </a:ext>
-                </a:extLst>
               </a:tr>
               <a:tr h="310896">
                 <a:tc>
@@ -5660,11 +5600,6 @@
                     </a:solidFill>
                   </a:tcPr>
                 </a:tc>
-                <a:extLst>
-                  <a:ext uri="{0D108BD9-81ED-4DB2-BD59-A6C34878D82A}">
-                    <a16:rowId xmlns:a16="http://schemas.microsoft.com/office/drawing/2014/main" val="10002"/>
-                  </a:ext>
-                </a:extLst>
               </a:tr>
               <a:tr h="310896">
                 <a:tc>
@@ -5736,11 +5671,6 @@
                     </a:solidFill>
                   </a:tcPr>
                 </a:tc>
-                <a:extLst>
-                  <a:ext uri="{0D108BD9-81ED-4DB2-BD59-A6C34878D82A}">
-                    <a16:rowId xmlns:a16="http://schemas.microsoft.com/office/drawing/2014/main" val="10003"/>
-                  </a:ext>
-                </a:extLst>
               </a:tr>
             </a:tbl>
           </a:graphicData>
@@ -5833,8 +5763,8 @@
         </p:blipFill>
         <p:spPr>
           <a:xfrm>
-            <a:off x="5699857" y="3675693"/>
-            <a:ext cx="6378673" cy="2770827"/>
+            <a:off x="8229600" y="1042416"/>
+            <a:ext cx="3550615" cy="1542349"/>
           </a:xfrm>
           <a:prstGeom prst="rect">
             <a:avLst/>
@@ -5850,7 +5780,7 @@
 </file>
 
 <file path=ppt/slides/slide6.xml><?xml version="1.0" encoding="utf-8"?>
-<p:sld xmlns:a="http://schemas.openxmlformats.org/drawingml/2006/main" xmlns:r="http://schemas.openxmlformats.org/officeDocument/2006/relationships" xmlns:p="http://schemas.openxmlformats.org/presentationml/2006/main">
+<p:sld xmlns:a="http://schemas.openxmlformats.org/drawingml/2006/main" xmlns:p="http://schemas.openxmlformats.org/presentationml/2006/main" xmlns:r="http://schemas.openxmlformats.org/officeDocument/2006/relationships">
   <p:cSld>
     <p:bg>
       <p:bgPr>
@@ -5866,14 +5796,7 @@
         <p:cNvGrpSpPr/>
         <p:nvPr/>
       </p:nvGrpSpPr>
-      <p:grpSpPr>
-        <a:xfrm>
-          <a:off x="0" y="0"/>
-          <a:ext cx="0" cy="0"/>
-          <a:chOff x="0" y="0"/>
-          <a:chExt cx="0" cy="0"/>
-        </a:xfrm>
-      </p:grpSpPr>
+      <p:grpSpPr/>
       <p:sp>
         <p:nvSpPr>
           <p:cNvPr id="2" name="Rectangle 1"/>
@@ -5914,7 +5837,6 @@
           <a:lstStyle/>
           <a:p>
             <a:pPr algn="ctr"/>
-            <a:endParaRPr/>
           </a:p>
         </p:txBody>
       </p:sp>
@@ -6028,7 +5950,6 @@
           <a:lstStyle/>
           <a:p>
             <a:pPr algn="ctr"/>
-            <a:endParaRPr/>
           </a:p>
         </p:txBody>
       </p:sp>
@@ -6130,7 +6051,7 @@
         </p:nvSpPr>
         <p:spPr>
           <a:xfrm>
-            <a:off x="411480" y="2786261"/>
+            <a:off x="411480" y="2779776"/>
             <a:ext cx="11368735" cy="3986784"/>
           </a:xfrm>
           <a:prstGeom prst="rect">
@@ -6231,17 +6152,11 @@
           <p:cNvGraphicFramePr>
             <a:graphicFrameLocks noGrp="1"/>
           </p:cNvGraphicFramePr>
-          <p:nvPr>
-            <p:extLst>
-              <p:ext uri="{D42A27DB-BD31-4B8C-83A1-F6EECF244321}">
-                <p14:modId xmlns:p14="http://schemas.microsoft.com/office/powerpoint/2010/main" val="3631052426"/>
-              </p:ext>
-            </p:extLst>
-          </p:nvPr>
+          <p:nvPr/>
         </p:nvGraphicFramePr>
         <p:xfrm>
-          <a:off x="7243864" y="2414016"/>
-          <a:ext cx="4794933" cy="1718814"/>
+          <a:off x="3093415" y="2414016"/>
+          <a:ext cx="8686800" cy="1243584"/>
         </p:xfrm>
         <a:graphic>
           <a:graphicData uri="http://schemas.openxmlformats.org/drawingml/2006/table">
@@ -6250,29 +6165,11 @@
                 <a:tableStyleId>{5C22544A-7EE6-4342-B048-85BDC9FD1C3A}</a:tableStyleId>
               </a:tblPr>
               <a:tblGrid>
-                <a:gridCol w="757094">
-                  <a:extLst>
-                    <a:ext uri="{9D8B030D-6E8A-4147-A177-3AD203B41FA5}">
-                      <a16:colId xmlns:a16="http://schemas.microsoft.com/office/drawing/2014/main" val="20000"/>
-                    </a:ext>
-                  </a:extLst>
-                </a:gridCol>
-                <a:gridCol w="1261824">
-                  <a:extLst>
-                    <a:ext uri="{9D8B030D-6E8A-4147-A177-3AD203B41FA5}">
-                      <a16:colId xmlns:a16="http://schemas.microsoft.com/office/drawing/2014/main" val="20001"/>
-                    </a:ext>
-                  </a:extLst>
-                </a:gridCol>
-                <a:gridCol w="2776015">
-                  <a:extLst>
-                    <a:ext uri="{9D8B030D-6E8A-4147-A177-3AD203B41FA5}">
-                      <a16:colId xmlns:a16="http://schemas.microsoft.com/office/drawing/2014/main" val="20002"/>
-                    </a:ext>
-                  </a:extLst>
-                </a:gridCol>
+                <a:gridCol w="1371600"/>
+                <a:gridCol w="2286000"/>
+                <a:gridCol w="5029200"/>
               </a:tblGrid>
-              <a:tr h="414581">
+              <a:tr h="310896">
                 <a:tc>
                   <a:txBody>
                     <a:bodyPr/>
@@ -6326,7 +6223,7 @@
                     <a:p>
                       <a:pPr algn="ctr"/>
                       <a:r>
-                        <a:rPr sz="1100" b="1" dirty="0">
+                        <a:rPr sz="1100" b="1">
                           <a:solidFill>
                             <a:srgbClr val="FFFFFF"/>
                           </a:solidFill>
@@ -6342,13 +6239,8 @@
                     </a:solidFill>
                   </a:tcPr>
                 </a:tc>
-                <a:extLst>
-                  <a:ext uri="{0D108BD9-81ED-4DB2-BD59-A6C34878D82A}">
-                    <a16:rowId xmlns:a16="http://schemas.microsoft.com/office/drawing/2014/main" val="10000"/>
-                  </a:ext>
-                </a:extLst>
               </a:tr>
-              <a:tr h="414581">
+              <a:tr h="310896">
                 <a:tc>
                   <a:txBody>
                     <a:bodyPr/>
@@ -6418,13 +6310,8 @@
                     </a:solidFill>
                   </a:tcPr>
                 </a:tc>
-                <a:extLst>
-                  <a:ext uri="{0D108BD9-81ED-4DB2-BD59-A6C34878D82A}">
-                    <a16:rowId xmlns:a16="http://schemas.microsoft.com/office/drawing/2014/main" val="10001"/>
-                  </a:ext>
-                </a:extLst>
               </a:tr>
-              <a:tr h="414581">
+              <a:tr h="310896">
                 <a:tc>
                   <a:txBody>
                     <a:bodyPr/>
@@ -6494,13 +6381,8 @@
                     </a:solidFill>
                   </a:tcPr>
                 </a:tc>
-                <a:extLst>
-                  <a:ext uri="{0D108BD9-81ED-4DB2-BD59-A6C34878D82A}">
-                    <a16:rowId xmlns:a16="http://schemas.microsoft.com/office/drawing/2014/main" val="10002"/>
-                  </a:ext>
-                </a:extLst>
               </a:tr>
-              <a:tr h="475071">
+              <a:tr h="310896">
                 <a:tc>
                   <a:txBody>
                     <a:bodyPr/>
@@ -6554,7 +6436,7 @@
                     <a:p>
                       <a:pPr algn="ctr"/>
                       <a:r>
-                        <a:rPr sz="1000" dirty="0">
+                        <a:rPr sz="1000">
                           <a:solidFill>
                             <a:srgbClr val="2C3E50"/>
                           </a:solidFill>
@@ -6570,11 +6452,6 @@
                     </a:solidFill>
                   </a:tcPr>
                 </a:tc>
-                <a:extLst>
-                  <a:ext uri="{0D108BD9-81ED-4DB2-BD59-A6C34878D82A}">
-                    <a16:rowId xmlns:a16="http://schemas.microsoft.com/office/drawing/2014/main" val="10003"/>
-                  </a:ext>
-                </a:extLst>
               </a:tr>
             </a:tbl>
           </a:graphicData>
@@ -6589,7 +6466,7 @@
 </file>
 
 <file path=ppt/slides/slide7.xml><?xml version="1.0" encoding="utf-8"?>
-<p:sld xmlns:a="http://schemas.openxmlformats.org/drawingml/2006/main" xmlns:r="http://schemas.openxmlformats.org/officeDocument/2006/relationships" xmlns:p="http://schemas.openxmlformats.org/presentationml/2006/main">
+<p:sld xmlns:a="http://schemas.openxmlformats.org/drawingml/2006/main" xmlns:p="http://schemas.openxmlformats.org/presentationml/2006/main" xmlns:r="http://schemas.openxmlformats.org/officeDocument/2006/relationships">
   <p:cSld>
     <p:bg>
       <p:bgPr>
@@ -6605,14 +6482,7 @@
         <p:cNvGrpSpPr/>
         <p:nvPr/>
       </p:nvGrpSpPr>
-      <p:grpSpPr>
-        <a:xfrm>
-          <a:off x="0" y="0"/>
-          <a:ext cx="0" cy="0"/>
-          <a:chOff x="0" y="0"/>
-          <a:chExt cx="0" cy="0"/>
-        </a:xfrm>
-      </p:grpSpPr>
+      <p:grpSpPr/>
       <p:sp>
         <p:nvSpPr>
           <p:cNvPr id="2" name="Rectangle 1"/>
@@ -6653,7 +6523,6 @@
           <a:lstStyle/>
           <a:p>
             <a:pPr algn="ctr"/>
-            <a:endParaRPr/>
           </a:p>
         </p:txBody>
       </p:sp>
@@ -6746,27 +6615,9 @@
                 <a:tableStyleId>{5C22544A-7EE6-4342-B048-85BDC9FD1C3A}</a:tableStyleId>
               </a:tblPr>
               <a:tblGrid>
-                <a:gridCol w="1828800">
-                  <a:extLst>
-                    <a:ext uri="{9D8B030D-6E8A-4147-A177-3AD203B41FA5}">
-                      <a16:colId xmlns:a16="http://schemas.microsoft.com/office/drawing/2014/main" val="20000"/>
-                    </a:ext>
-                  </a:extLst>
-                </a:gridCol>
-                <a:gridCol w="2011680">
-                  <a:extLst>
-                    <a:ext uri="{9D8B030D-6E8A-4147-A177-3AD203B41FA5}">
-                      <a16:colId xmlns:a16="http://schemas.microsoft.com/office/drawing/2014/main" val="20001"/>
-                    </a:ext>
-                  </a:extLst>
-                </a:gridCol>
-                <a:gridCol w="3017520">
-                  <a:extLst>
-                    <a:ext uri="{9D8B030D-6E8A-4147-A177-3AD203B41FA5}">
-                      <a16:colId xmlns:a16="http://schemas.microsoft.com/office/drawing/2014/main" val="20002"/>
-                    </a:ext>
-                  </a:extLst>
-                </a:gridCol>
+                <a:gridCol w="1828800"/>
+                <a:gridCol w="2011680"/>
+                <a:gridCol w="3017520"/>
               </a:tblGrid>
               <a:tr h="310896">
                 <a:tc>
@@ -6838,11 +6689,6 @@
                     </a:solidFill>
                   </a:tcPr>
                 </a:tc>
-                <a:extLst>
-                  <a:ext uri="{0D108BD9-81ED-4DB2-BD59-A6C34878D82A}">
-                    <a16:rowId xmlns:a16="http://schemas.microsoft.com/office/drawing/2014/main" val="10000"/>
-                  </a:ext>
-                </a:extLst>
               </a:tr>
               <a:tr h="310896">
                 <a:tc>
@@ -6914,11 +6760,6 @@
                     </a:solidFill>
                   </a:tcPr>
                 </a:tc>
-                <a:extLst>
-                  <a:ext uri="{0D108BD9-81ED-4DB2-BD59-A6C34878D82A}">
-                    <a16:rowId xmlns:a16="http://schemas.microsoft.com/office/drawing/2014/main" val="10001"/>
-                  </a:ext>
-                </a:extLst>
               </a:tr>
               <a:tr h="310896">
                 <a:tc>
@@ -6990,11 +6831,6 @@
                     </a:solidFill>
                   </a:tcPr>
                 </a:tc>
-                <a:extLst>
-                  <a:ext uri="{0D108BD9-81ED-4DB2-BD59-A6C34878D82A}">
-                    <a16:rowId xmlns:a16="http://schemas.microsoft.com/office/drawing/2014/main" val="10002"/>
-                  </a:ext>
-                </a:extLst>
               </a:tr>
               <a:tr h="310896">
                 <a:tc>
@@ -7066,11 +6902,6 @@
                     </a:solidFill>
                   </a:tcPr>
                 </a:tc>
-                <a:extLst>
-                  <a:ext uri="{0D108BD9-81ED-4DB2-BD59-A6C34878D82A}">
-                    <a16:rowId xmlns:a16="http://schemas.microsoft.com/office/drawing/2014/main" val="10003"/>
-                  </a:ext>
-                </a:extLst>
               </a:tr>
               <a:tr h="310896">
                 <a:tc>
@@ -7142,11 +6973,6 @@
                     </a:solidFill>
                   </a:tcPr>
                 </a:tc>
-                <a:extLst>
-                  <a:ext uri="{0D108BD9-81ED-4DB2-BD59-A6C34878D82A}">
-                    <a16:rowId xmlns:a16="http://schemas.microsoft.com/office/drawing/2014/main" val="10004"/>
-                  </a:ext>
-                </a:extLst>
               </a:tr>
               <a:tr h="310896">
                 <a:tc>
@@ -7218,11 +7044,6 @@
                     </a:solidFill>
                   </a:tcPr>
                 </a:tc>
-                <a:extLst>
-                  <a:ext uri="{0D108BD9-81ED-4DB2-BD59-A6C34878D82A}">
-                    <a16:rowId xmlns:a16="http://schemas.microsoft.com/office/drawing/2014/main" val="10005"/>
-                  </a:ext>
-                </a:extLst>
               </a:tr>
               <a:tr h="310896">
                 <a:tc>
@@ -7294,11 +7115,6 @@
                     </a:solidFill>
                   </a:tcPr>
                 </a:tc>
-                <a:extLst>
-                  <a:ext uri="{0D108BD9-81ED-4DB2-BD59-A6C34878D82A}">
-                    <a16:rowId xmlns:a16="http://schemas.microsoft.com/office/drawing/2014/main" val="10006"/>
-                  </a:ext>
-                </a:extLst>
               </a:tr>
               <a:tr h="310896">
                 <a:tc>
@@ -7370,11 +7186,6 @@
                     </a:solidFill>
                   </a:tcPr>
                 </a:tc>
-                <a:extLst>
-                  <a:ext uri="{0D108BD9-81ED-4DB2-BD59-A6C34878D82A}">
-                    <a16:rowId xmlns:a16="http://schemas.microsoft.com/office/drawing/2014/main" val="10007"/>
-                  </a:ext>
-                </a:extLst>
               </a:tr>
             </a:tbl>
           </a:graphicData>
@@ -7388,7 +7199,7 @@
         </p:nvSpPr>
         <p:spPr>
           <a:xfrm>
-            <a:off x="411479" y="4012595"/>
+            <a:off x="7680960" y="1042416"/>
             <a:ext cx="4099255" cy="320040"/>
           </a:xfrm>
           <a:prstGeom prst="rect">
@@ -7404,7 +7215,7 @@
           <a:p>
             <a:pPr algn="l"/>
             <a:r>
-              <a:rPr sz="1300" b="1" i="0" dirty="0">
+              <a:rPr sz="1300" b="1" i="0">
                 <a:solidFill>
                   <a:srgbClr val="2980B9"/>
                 </a:solidFill>
@@ -7423,7 +7234,7 @@
         </p:nvSpPr>
         <p:spPr>
           <a:xfrm>
-            <a:off x="411480" y="4443984"/>
+            <a:off x="7680960" y="1408176"/>
             <a:ext cx="4099255" cy="2743200"/>
           </a:xfrm>
           <a:prstGeom prst="rect">
@@ -7443,29 +7254,14 @@
               </a:spcBef>
             </a:pPr>
             <a:r>
-              <a:rPr sz="1200" dirty="0">
+              <a:rPr sz="1200">
                 <a:solidFill>
                   <a:srgbClr val="2C3E50"/>
                 </a:solidFill>
                 <a:latin typeface="Courier New"/>
               </a:rPr>
-              <a:t>Champion:     </a:t>
-            </a:r>
-            <a:r>
-              <a:rPr sz="1200" dirty="0" err="1">
-                <a:solidFill>
-                  <a:srgbClr val="2C3E50"/>
-                </a:solidFill>
-                <a:latin typeface="Courier New"/>
-              </a:rPr>
-              <a:t>XGBoost</a:t>
-            </a:r>
-            <a:endParaRPr sz="1200" dirty="0">
-              <a:solidFill>
-                <a:srgbClr val="2C3E50"/>
-              </a:solidFill>
-              <a:latin typeface="Courier New"/>
-            </a:endParaRPr>
+              <a:t>Champion:     XGBoost</a:t>
+            </a:r>
           </a:p>
           <a:p>
             <a:pPr>
@@ -7474,67 +7270,13 @@
               </a:spcBef>
             </a:pPr>
             <a:r>
-              <a:rPr sz="1200" dirty="0">
+              <a:rPr sz="1200">
                 <a:solidFill>
                   <a:srgbClr val="2C3E50"/>
                 </a:solidFill>
                 <a:latin typeface="Courier New"/>
               </a:rPr>
-              <a:t>Best params:  </a:t>
-            </a:r>
-            <a:r>
-              <a:rPr sz="1200" dirty="0" err="1">
-                <a:solidFill>
-                  <a:srgbClr val="2C3E50"/>
-                </a:solidFill>
-                <a:latin typeface="Courier New"/>
-              </a:rPr>
-              <a:t>learning_rate</a:t>
-            </a:r>
-            <a:r>
-              <a:rPr sz="1200" dirty="0">
-                <a:solidFill>
-                  <a:srgbClr val="2C3E50"/>
-                </a:solidFill>
-                <a:latin typeface="Courier New"/>
-              </a:rPr>
-              <a:t>=0.05, </a:t>
-            </a:r>
-            <a:r>
-              <a:rPr sz="1200" dirty="0" err="1">
-                <a:solidFill>
-                  <a:srgbClr val="2C3E50"/>
-                </a:solidFill>
-                <a:latin typeface="Courier New"/>
-              </a:rPr>
-              <a:t>max_depth</a:t>
-            </a:r>
-            <a:r>
-              <a:rPr sz="1200" dirty="0">
-                <a:solidFill>
-                  <a:srgbClr val="2C3E50"/>
-                </a:solidFill>
-                <a:latin typeface="Courier New"/>
-              </a:rPr>
-              <a:t>=3, </a:t>
-            </a:r>
-            <a:r>
-              <a:rPr sz="1200" dirty="0" err="1">
-                <a:solidFill>
-                  <a:srgbClr val="2C3E50"/>
-                </a:solidFill>
-                <a:latin typeface="Courier New"/>
-              </a:rPr>
-              <a:t>n_estimators</a:t>
-            </a:r>
-            <a:r>
-              <a:rPr sz="1200" dirty="0">
-                <a:solidFill>
-                  <a:srgbClr val="2C3E50"/>
-                </a:solidFill>
-                <a:latin typeface="Courier New"/>
-              </a:rPr>
-              <a:t>=400</a:t>
+              <a:t>Best params:  learning_rate=0.05, max_depth=3, n_estimators=400</a:t>
             </a:r>
           </a:p>
           <a:p>
@@ -7544,7 +7286,7 @@
               </a:spcBef>
             </a:pPr>
             <a:r>
-              <a:rPr sz="1200" dirty="0">
+              <a:rPr sz="1200">
                 <a:solidFill>
                   <a:srgbClr val="2C3E50"/>
                 </a:solidFill>
@@ -7560,7 +7302,7 @@
               </a:spcBef>
             </a:pPr>
             <a:r>
-              <a:rPr sz="1200" dirty="0">
+              <a:rPr sz="1200">
                 <a:solidFill>
                   <a:srgbClr val="2C3E50"/>
                 </a:solidFill>
@@ -7575,12 +7317,15 @@
                 <a:spcPts val="300"/>
               </a:spcBef>
             </a:pPr>
-            <a:endParaRPr sz="1200" dirty="0">
-              <a:solidFill>
-                <a:srgbClr val="2C3E50"/>
-              </a:solidFill>
-              <a:latin typeface="Courier New"/>
-            </a:endParaRPr>
+            <a:r>
+              <a:rPr sz="1200">
+                <a:solidFill>
+                  <a:srgbClr val="2C3E50"/>
+                </a:solidFill>
+                <a:latin typeface="Courier New"/>
+              </a:rPr>
+              <a:t/>
+            </a:r>
           </a:p>
           <a:p>
             <a:pPr>
@@ -7589,31 +7334,13 @@
               </a:spcBef>
             </a:pPr>
             <a:r>
-              <a:rPr sz="1200" dirty="0">
+              <a:rPr sz="1200">
                 <a:solidFill>
                   <a:srgbClr val="2C3E50"/>
                 </a:solidFill>
                 <a:latin typeface="Courier New"/>
               </a:rPr>
-              <a:t>Refit: clone(</a:t>
-            </a:r>
-            <a:r>
-              <a:rPr sz="1200" dirty="0" err="1">
-                <a:solidFill>
-                  <a:srgbClr val="2C3E50"/>
-                </a:solidFill>
-                <a:latin typeface="Courier New"/>
-              </a:rPr>
-              <a:t>best_estimator</a:t>
-            </a:r>
-            <a:r>
-              <a:rPr sz="1200" dirty="0">
-                <a:solidFill>
-                  <a:srgbClr val="2C3E50"/>
-                </a:solidFill>
-                <a:latin typeface="Courier New"/>
-              </a:rPr>
-              <a:t>_)</a:t>
+              <a:t>Refit: clone(best_estimator_)</a:t>
             </a:r>
           </a:p>
           <a:p>
@@ -7623,49 +7350,13 @@
               </a:spcBef>
             </a:pPr>
             <a:r>
-              <a:rPr sz="1200" dirty="0">
+              <a:rPr sz="1200">
                 <a:solidFill>
                   <a:srgbClr val="2C3E50"/>
                 </a:solidFill>
                 <a:latin typeface="Courier New"/>
               </a:rPr>
-              <a:t>       .fit(</a:t>
-            </a:r>
-            <a:r>
-              <a:rPr sz="1200" dirty="0" err="1">
-                <a:solidFill>
-                  <a:srgbClr val="2C3E50"/>
-                </a:solidFill>
-                <a:latin typeface="Courier New"/>
-              </a:rPr>
-              <a:t>X_train</a:t>
-            </a:r>
-            <a:r>
-              <a:rPr sz="1200" dirty="0">
-                <a:solidFill>
-                  <a:srgbClr val="2C3E50"/>
-                </a:solidFill>
-                <a:latin typeface="Courier New"/>
-              </a:rPr>
-              <a:t>, </a:t>
-            </a:r>
-            <a:r>
-              <a:rPr sz="1200" dirty="0" err="1">
-                <a:solidFill>
-                  <a:srgbClr val="2C3E50"/>
-                </a:solidFill>
-                <a:latin typeface="Courier New"/>
-              </a:rPr>
-              <a:t>y_train</a:t>
-            </a:r>
-            <a:r>
-              <a:rPr sz="1200" dirty="0">
-                <a:solidFill>
-                  <a:srgbClr val="2C3E50"/>
-                </a:solidFill>
-                <a:latin typeface="Courier New"/>
-              </a:rPr>
-              <a:t>)</a:t>
+              <a:t>       .fit(X_train, y_train)</a:t>
             </a:r>
           </a:p>
           <a:p>
@@ -7675,7 +7366,7 @@
               </a:spcBef>
             </a:pPr>
             <a:r>
-              <a:rPr sz="1200" dirty="0">
+              <a:rPr sz="1200">
                 <a:solidFill>
                   <a:srgbClr val="2C3E50"/>
                 </a:solidFill>
@@ -7695,7 +7386,7 @@
 </file>
 
 <file path=ppt/slides/slide8.xml><?xml version="1.0" encoding="utf-8"?>
-<p:sld xmlns:a="http://schemas.openxmlformats.org/drawingml/2006/main" xmlns:r="http://schemas.openxmlformats.org/officeDocument/2006/relationships" xmlns:p="http://schemas.openxmlformats.org/presentationml/2006/main">
+<p:sld xmlns:a="http://schemas.openxmlformats.org/drawingml/2006/main" xmlns:p="http://schemas.openxmlformats.org/presentationml/2006/main" xmlns:r="http://schemas.openxmlformats.org/officeDocument/2006/relationships">
   <p:cSld>
     <p:bg>
       <p:bgPr>
@@ -7711,14 +7402,7 @@
         <p:cNvGrpSpPr/>
         <p:nvPr/>
       </p:nvGrpSpPr>
-      <p:grpSpPr>
-        <a:xfrm>
-          <a:off x="0" y="0"/>
-          <a:ext cx="0" cy="0"/>
-          <a:chOff x="0" y="0"/>
-          <a:chExt cx="0" cy="0"/>
-        </a:xfrm>
-      </p:grpSpPr>
+      <p:grpSpPr/>
       <p:sp>
         <p:nvSpPr>
           <p:cNvPr id="2" name="Rectangle 1"/>
@@ -7759,7 +7443,6 @@
           <a:lstStyle/>
           <a:p>
             <a:pPr algn="ctr"/>
-            <a:endParaRPr/>
           </a:p>
         </p:txBody>
       </p:sp>
@@ -7887,27 +7570,9 @@
                 <a:tableStyleId>{5C22544A-7EE6-4342-B048-85BDC9FD1C3A}</a:tableStyleId>
               </a:tblPr>
               <a:tblGrid>
-                <a:gridCol w="2926080">
-                  <a:extLst>
-                    <a:ext uri="{9D8B030D-6E8A-4147-A177-3AD203B41FA5}">
-                      <a16:colId xmlns:a16="http://schemas.microsoft.com/office/drawing/2014/main" val="20000"/>
-                    </a:ext>
-                  </a:extLst>
-                </a:gridCol>
-                <a:gridCol w="1371600">
-                  <a:extLst>
-                    <a:ext uri="{9D8B030D-6E8A-4147-A177-3AD203B41FA5}">
-                      <a16:colId xmlns:a16="http://schemas.microsoft.com/office/drawing/2014/main" val="20001"/>
-                    </a:ext>
-                  </a:extLst>
-                </a:gridCol>
-                <a:gridCol w="1188720">
-                  <a:extLst>
-                    <a:ext uri="{9D8B030D-6E8A-4147-A177-3AD203B41FA5}">
-                      <a16:colId xmlns:a16="http://schemas.microsoft.com/office/drawing/2014/main" val="20002"/>
-                    </a:ext>
-                  </a:extLst>
-                </a:gridCol>
+                <a:gridCol w="2926080"/>
+                <a:gridCol w="1371600"/>
+                <a:gridCol w="1188720"/>
               </a:tblGrid>
               <a:tr h="310896">
                 <a:tc>
@@ -7979,11 +7644,6 @@
                     </a:solidFill>
                   </a:tcPr>
                 </a:tc>
-                <a:extLst>
-                  <a:ext uri="{0D108BD9-81ED-4DB2-BD59-A6C34878D82A}">
-                    <a16:rowId xmlns:a16="http://schemas.microsoft.com/office/drawing/2014/main" val="10000"/>
-                  </a:ext>
-                </a:extLst>
               </a:tr>
               <a:tr h="310896">
                 <a:tc>
@@ -8055,11 +7715,6 @@
                     </a:solidFill>
                   </a:tcPr>
                 </a:tc>
-                <a:extLst>
-                  <a:ext uri="{0D108BD9-81ED-4DB2-BD59-A6C34878D82A}">
-                    <a16:rowId xmlns:a16="http://schemas.microsoft.com/office/drawing/2014/main" val="10001"/>
-                  </a:ext>
-                </a:extLst>
               </a:tr>
               <a:tr h="310896">
                 <a:tc>
@@ -8131,11 +7786,6 @@
                     </a:solidFill>
                   </a:tcPr>
                 </a:tc>
-                <a:extLst>
-                  <a:ext uri="{0D108BD9-81ED-4DB2-BD59-A6C34878D82A}">
-                    <a16:rowId xmlns:a16="http://schemas.microsoft.com/office/drawing/2014/main" val="10002"/>
-                  </a:ext>
-                </a:extLst>
               </a:tr>
               <a:tr h="310896">
                 <a:tc>
@@ -8207,11 +7857,6 @@
                     </a:solidFill>
                   </a:tcPr>
                 </a:tc>
-                <a:extLst>
-                  <a:ext uri="{0D108BD9-81ED-4DB2-BD59-A6C34878D82A}">
-                    <a16:rowId xmlns:a16="http://schemas.microsoft.com/office/drawing/2014/main" val="10003"/>
-                  </a:ext>
-                </a:extLst>
               </a:tr>
             </a:tbl>
           </a:graphicData>
@@ -8271,20 +7916,8 @@
                 <a:tableStyleId>{5C22544A-7EE6-4342-B048-85BDC9FD1C3A}</a:tableStyleId>
               </a:tblPr>
               <a:tblGrid>
-                <a:gridCol w="2103120">
-                  <a:extLst>
-                    <a:ext uri="{9D8B030D-6E8A-4147-A177-3AD203B41FA5}">
-                      <a16:colId xmlns:a16="http://schemas.microsoft.com/office/drawing/2014/main" val="20000"/>
-                    </a:ext>
-                  </a:extLst>
-                </a:gridCol>
-                <a:gridCol w="1097280">
-                  <a:extLst>
-                    <a:ext uri="{9D8B030D-6E8A-4147-A177-3AD203B41FA5}">
-                      <a16:colId xmlns:a16="http://schemas.microsoft.com/office/drawing/2014/main" val="20001"/>
-                    </a:ext>
-                  </a:extLst>
-                </a:gridCol>
+                <a:gridCol w="2103120"/>
+                <a:gridCol w="1097280"/>
               </a:tblGrid>
               <a:tr h="310896">
                 <a:tc>
@@ -8333,11 +7966,6 @@
                     </a:solidFill>
                   </a:tcPr>
                 </a:tc>
-                <a:extLst>
-                  <a:ext uri="{0D108BD9-81ED-4DB2-BD59-A6C34878D82A}">
-                    <a16:rowId xmlns:a16="http://schemas.microsoft.com/office/drawing/2014/main" val="10000"/>
-                  </a:ext>
-                </a:extLst>
               </a:tr>
               <a:tr h="310896">
                 <a:tc>
@@ -8386,11 +8014,6 @@
                     </a:solidFill>
                   </a:tcPr>
                 </a:tc>
-                <a:extLst>
-                  <a:ext uri="{0D108BD9-81ED-4DB2-BD59-A6C34878D82A}">
-                    <a16:rowId xmlns:a16="http://schemas.microsoft.com/office/drawing/2014/main" val="10001"/>
-                  </a:ext>
-                </a:extLst>
               </a:tr>
               <a:tr h="310896">
                 <a:tc>
@@ -8439,11 +8062,6 @@
                     </a:solidFill>
                   </a:tcPr>
                 </a:tc>
-                <a:extLst>
-                  <a:ext uri="{0D108BD9-81ED-4DB2-BD59-A6C34878D82A}">
-                    <a16:rowId xmlns:a16="http://schemas.microsoft.com/office/drawing/2014/main" val="10002"/>
-                  </a:ext>
-                </a:extLst>
               </a:tr>
               <a:tr h="310896">
                 <a:tc>
@@ -8492,11 +8110,6 @@
                     </a:solidFill>
                   </a:tcPr>
                 </a:tc>
-                <a:extLst>
-                  <a:ext uri="{0D108BD9-81ED-4DB2-BD59-A6C34878D82A}">
-                    <a16:rowId xmlns:a16="http://schemas.microsoft.com/office/drawing/2014/main" val="10003"/>
-                  </a:ext>
-                </a:extLst>
               </a:tr>
             </a:tbl>
           </a:graphicData>
@@ -8535,7 +8148,7 @@
 </file>
 
 <file path=ppt/slides/slide9.xml><?xml version="1.0" encoding="utf-8"?>
-<p:sld xmlns:a="http://schemas.openxmlformats.org/drawingml/2006/main" xmlns:r="http://schemas.openxmlformats.org/officeDocument/2006/relationships" xmlns:p="http://schemas.openxmlformats.org/presentationml/2006/main">
+<p:sld xmlns:a="http://schemas.openxmlformats.org/drawingml/2006/main" xmlns:p="http://schemas.openxmlformats.org/presentationml/2006/main" xmlns:r="http://schemas.openxmlformats.org/officeDocument/2006/relationships">
   <p:cSld>
     <p:bg>
       <p:bgPr>
@@ -8551,14 +8164,7 @@
         <p:cNvGrpSpPr/>
         <p:nvPr/>
       </p:nvGrpSpPr>
-      <p:grpSpPr>
-        <a:xfrm>
-          <a:off x="0" y="0"/>
-          <a:ext cx="0" cy="0"/>
-          <a:chOff x="0" y="0"/>
-          <a:chExt cx="0" cy="0"/>
-        </a:xfrm>
-      </p:grpSpPr>
+      <p:grpSpPr/>
       <p:sp>
         <p:nvSpPr>
           <p:cNvPr id="2" name="Rectangle 1"/>
@@ -8599,7 +8205,6 @@
           <a:lstStyle/>
           <a:p>
             <a:pPr algn="ctr"/>
-            <a:endParaRPr/>
           </a:p>
         </p:txBody>
       </p:sp>
@@ -8718,7 +8323,7 @@
         </p:nvGraphicFramePr>
         <p:xfrm>
           <a:off x="411480" y="1389888"/>
-          <a:ext cx="5669280" cy="1018032"/>
+          <a:ext cx="5669280" cy="932688"/>
         </p:xfrm>
         <a:graphic>
           <a:graphicData uri="http://schemas.openxmlformats.org/drawingml/2006/table">
@@ -8727,27 +8332,9 @@
                 <a:tableStyleId>{5C22544A-7EE6-4342-B048-85BDC9FD1C3A}</a:tableStyleId>
               </a:tblPr>
               <a:tblGrid>
-                <a:gridCol w="2286000">
-                  <a:extLst>
-                    <a:ext uri="{9D8B030D-6E8A-4147-A177-3AD203B41FA5}">
-                      <a16:colId xmlns:a16="http://schemas.microsoft.com/office/drawing/2014/main" val="20000"/>
-                    </a:ext>
-                  </a:extLst>
-                </a:gridCol>
-                <a:gridCol w="2560320">
-                  <a:extLst>
-                    <a:ext uri="{9D8B030D-6E8A-4147-A177-3AD203B41FA5}">
-                      <a16:colId xmlns:a16="http://schemas.microsoft.com/office/drawing/2014/main" val="20001"/>
-                    </a:ext>
-                  </a:extLst>
-                </a:gridCol>
-                <a:gridCol w="822960">
-                  <a:extLst>
-                    <a:ext uri="{9D8B030D-6E8A-4147-A177-3AD203B41FA5}">
-                      <a16:colId xmlns:a16="http://schemas.microsoft.com/office/drawing/2014/main" val="20002"/>
-                    </a:ext>
-                  </a:extLst>
-                </a:gridCol>
+                <a:gridCol w="2286000"/>
+                <a:gridCol w="2560320"/>
+                <a:gridCol w="822960"/>
               </a:tblGrid>
               <a:tr h="310896">
                 <a:tc>
@@ -8819,11 +8406,6 @@
                     </a:solidFill>
                   </a:tcPr>
                 </a:tc>
-                <a:extLst>
-                  <a:ext uri="{0D108BD9-81ED-4DB2-BD59-A6C34878D82A}">
-                    <a16:rowId xmlns:a16="http://schemas.microsoft.com/office/drawing/2014/main" val="10000"/>
-                  </a:ext>
-                </a:extLst>
               </a:tr>
               <a:tr h="310896">
                 <a:tc>
@@ -8862,7 +8444,7 @@
                           </a:solidFill>
                           <a:latin typeface="Calibri"/>
                         </a:rPr>
-                        <a:t>Customer leaves uncontacted → lost LTV (~$500+)</a:t>
+                        <a:t>Customer leaves uncontacted → lost lifetime value</a:t>
                       </a:r>
                     </a:p>
                   </a:txBody>
@@ -8895,11 +8477,6 @@
                     </a:solidFill>
                   </a:tcPr>
                 </a:tc>
-                <a:extLst>
-                  <a:ext uri="{0D108BD9-81ED-4DB2-BD59-A6C34878D82A}">
-                    <a16:rowId xmlns:a16="http://schemas.microsoft.com/office/drawing/2014/main" val="10001"/>
-                  </a:ext>
-                </a:extLst>
               </a:tr>
               <a:tr h="310896">
                 <a:tc>
@@ -8938,7 +8515,7 @@
                           </a:solidFill>
                           <a:latin typeface="Calibri"/>
                         </a:rPr>
-                        <a:t>Wasted retention offer (~$30 voucher)</a:t>
+                        <a:t>Wasted retention offer — comparatively cheap, recoverable</a:t>
                       </a:r>
                     </a:p>
                   </a:txBody>
@@ -8971,11 +8548,6 @@
                     </a:solidFill>
                   </a:tcPr>
                 </a:tc>
-                <a:extLst>
-                  <a:ext uri="{0D108BD9-81ED-4DB2-BD59-A6C34878D82A}">
-                    <a16:rowId xmlns:a16="http://schemas.microsoft.com/office/drawing/2014/main" val="10002"/>
-                  </a:ext>
-                </a:extLst>
               </a:tr>
             </a:tbl>
           </a:graphicData>
@@ -9050,7 +8622,7 @@
                 </a:solidFill>
                 <a:latin typeface="Calibri"/>
               </a:rPr>
-              <a:t>◆  FN cost &gt;&gt; FP cost → lower classification threshold below default 0.50.</a:t>
+              <a:t>◆  FN far costlier than FP → prioritise recall; require recall ≥ 80%.</a:t>
             </a:r>
           </a:p>
           <a:p>
@@ -9066,7 +8638,23 @@
                 </a:solidFill>
                 <a:latin typeface="Calibri"/>
               </a:rPr>
-              <a:t>◆  Selected threshold 0.61: achieves ≥80% recall on validation folds.</a:t>
+              <a:t>◆  Among thresholds meeting the floor, 0.61 is the highest — limits false positives.</a:t>
+            </a:r>
+          </a:p>
+          <a:p>
+            <a:pPr algn="l">
+              <a:spcBef>
+                <a:spcPts val="300"/>
+              </a:spcBef>
+            </a:pPr>
+            <a:r>
+              <a:rPr sz="1200">
+                <a:solidFill>
+                  <a:srgbClr val="2C3E50"/>
+                </a:solidFill>
+                <a:latin typeface="Calibri"/>
+              </a:rPr>
+              <a:t>◆  SMOTE inflates predicted probabilities, so the operating point sits above 0.50, not below.</a:t>
             </a:r>
           </a:p>
           <a:p>

</xml_diff>

<commit_message>
Fix slide-6 layout: stack family table below bullets to eliminate overlap
Co-Authored-By: Claude Opus 4.8 <noreply@anthropic.com>
</commit_message>
<xml_diff>
--- a/Week 1/Wk1_Capstone/group3.pptx
+++ b/Week 1/Wk1_Capstone/group3.pptx
@@ -6052,7 +6052,7 @@
         <p:spPr>
           <a:xfrm>
             <a:off x="411480" y="2779776"/>
-            <a:ext cx="11368735" cy="3986784"/>
+            <a:ext cx="11368735" cy="1920240"/>
           </a:xfrm>
           <a:prstGeom prst="rect">
             <a:avLst/>
@@ -6146,17 +6146,52 @@
           </a:p>
         </p:txBody>
       </p:sp>
+      <p:sp>
+        <p:nvSpPr>
+          <p:cNvPr id="9" name="TextBox 8"/>
+          <p:cNvSpPr txBox="1"/>
+          <p:nvPr/>
+        </p:nvSpPr>
+        <p:spPr>
+          <a:xfrm>
+            <a:off x="411480" y="4791456"/>
+            <a:ext cx="11368735" cy="320040"/>
+          </a:xfrm>
+          <a:prstGeom prst="rect">
+            <a:avLst/>
+          </a:prstGeom>
+          <a:noFill/>
+        </p:spPr>
+        <p:txBody>
+          <a:bodyPr wrap="square">
+            <a:spAutoFit/>
+          </a:bodyPr>
+          <a:lstStyle/>
+          <a:p>
+            <a:pPr algn="l"/>
+            <a:r>
+              <a:rPr sz="1300" b="1" i="0">
+                <a:solidFill>
+                  <a:srgbClr val="2980B9"/>
+                </a:solidFill>
+                <a:latin typeface="Calibri"/>
+              </a:rPr>
+              <a:t>Model families considered</a:t>
+            </a:r>
+          </a:p>
+        </p:txBody>
+      </p:sp>
       <p:graphicFrame>
         <p:nvGraphicFramePr>
-          <p:cNvPr id="9" name="Table 8"/>
+          <p:cNvPr id="10" name="Table 9"/>
           <p:cNvGraphicFramePr>
             <a:graphicFrameLocks noGrp="1"/>
           </p:cNvGraphicFramePr>
           <p:nvPr/>
         </p:nvGraphicFramePr>
         <p:xfrm>
-          <a:off x="3093415" y="2414016"/>
-          <a:ext cx="8686800" cy="1243584"/>
+          <a:off x="411480" y="5157216"/>
+          <a:ext cx="11338560" cy="1243584"/>
         </p:xfrm>
         <a:graphic>
           <a:graphicData uri="http://schemas.openxmlformats.org/drawingml/2006/table">
@@ -6165,9 +6200,9 @@
                 <a:tableStyleId>{5C22544A-7EE6-4342-B048-85BDC9FD1C3A}</a:tableStyleId>
               </a:tblPr>
               <a:tblGrid>
-                <a:gridCol w="1371600"/>
-                <a:gridCol w="2286000"/>
-                <a:gridCol w="5029200"/>
+                <a:gridCol w="1645920"/>
+                <a:gridCol w="2560320"/>
+                <a:gridCol w="7132320"/>
               </a:tblGrid>
               <a:tr h="310896">
                 <a:tc>

</xml_diff>

<commit_message>
Update member full names + remove roles from title slide
Co-Authored-By: Claude Opus 4.8 <noreply@anthropic.com>
</commit_message>
<xml_diff>
--- a/Week 1/Wk1_Capstone/group3.pptx
+++ b/Week 1/Wk1_Capstone/group3.pptx
@@ -3283,7 +3283,7 @@
                 </a:solidFill>
                 <a:latin typeface="Calibri"/>
               </a:rPr>
-              <a:t>  Joyce Yeo  —  SNAIC Learner</a:t>
+              <a:t>  YEO XIU JUAN</a:t>
             </a:r>
           </a:p>
         </p:txBody>
@@ -3318,7 +3318,7 @@
                 </a:solidFill>
                 <a:latin typeface="Calibri"/>
               </a:rPr>
-              <a:t>  KhoonSeng  —  SNAIC Learner</a:t>
+              <a:t>  LIM KHOON SENG</a:t>
             </a:r>
           </a:p>
         </p:txBody>
@@ -3353,7 +3353,7 @@
                 </a:solidFill>
                 <a:latin typeface="Calibri"/>
               </a:rPr>
-              <a:t>  Lai Kin Wah  —  SNAIC Learner</a:t>
+              <a:t>  LAI KIN WAH</a:t>
             </a:r>
           </a:p>
         </p:txBody>
@@ -3698,7 +3698,7 @@
                           </a:solidFill>
                           <a:latin typeface="Calibri"/>
                         </a:rPr>
-                        <a:t>KhoonSeng</a:t>
+                        <a:t>LIM KHOON SENG</a:t>
                       </a:r>
                     </a:p>
                   </a:txBody>
@@ -3721,7 +3721,7 @@
                           </a:solidFill>
                           <a:latin typeface="Calibri"/>
                         </a:rPr>
-                        <a:t>Joyce Yeo</a:t>
+                        <a:t>YEO XIU JUAN</a:t>
                       </a:r>
                     </a:p>
                   </a:txBody>
@@ -3769,7 +3769,7 @@
                           </a:solidFill>
                           <a:latin typeface="Calibri"/>
                         </a:rPr>
-                        <a:t>Joyce Yeo</a:t>
+                        <a:t>YEO XIU JUAN</a:t>
                       </a:r>
                     </a:p>
                   </a:txBody>
@@ -3792,7 +3792,7 @@
                           </a:solidFill>
                           <a:latin typeface="Calibri"/>
                         </a:rPr>
-                        <a:t>Lai Kin Wah</a:t>
+                        <a:t>LAI KIN WAH</a:t>
                       </a:r>
                     </a:p>
                   </a:txBody>
@@ -3840,7 +3840,7 @@
                           </a:solidFill>
                           <a:latin typeface="Calibri"/>
                         </a:rPr>
-                        <a:t>Lai Kin Wah</a:t>
+                        <a:t>LAI KIN WAH</a:t>
                       </a:r>
                     </a:p>
                   </a:txBody>
@@ -3863,7 +3863,7 @@
                           </a:solidFill>
                           <a:latin typeface="Calibri"/>
                         </a:rPr>
-                        <a:t>KhoonSeng</a:t>
+                        <a:t>LIM KHOON SENG</a:t>
                       </a:r>
                     </a:p>
                   </a:txBody>
@@ -3911,7 +3911,7 @@
                           </a:solidFill>
                           <a:latin typeface="Calibri"/>
                         </a:rPr>
-                        <a:t>KhoonSeng</a:t>
+                        <a:t>LIM KHOON SENG</a:t>
                       </a:r>
                     </a:p>
                   </a:txBody>
@@ -3934,7 +3934,7 @@
                           </a:solidFill>
                           <a:latin typeface="Calibri"/>
                         </a:rPr>
-                        <a:t>Joyce Yeo</a:t>
+                        <a:t>YEO XIU JUAN</a:t>
                       </a:r>
                     </a:p>
                   </a:txBody>
@@ -3982,7 +3982,7 @@
                           </a:solidFill>
                           <a:latin typeface="Calibri"/>
                         </a:rPr>
-                        <a:t>Joyce Yeo</a:t>
+                        <a:t>YEO XIU JUAN</a:t>
                       </a:r>
                     </a:p>
                   </a:txBody>
@@ -4005,7 +4005,7 @@
                           </a:solidFill>
                           <a:latin typeface="Calibri"/>
                         </a:rPr>
-                        <a:t>Lai Kin Wah</a:t>
+                        <a:t>LAI KIN WAH</a:t>
                       </a:r>
                     </a:p>
                   </a:txBody>
@@ -4053,7 +4053,7 @@
                           </a:solidFill>
                           <a:latin typeface="Calibri"/>
                         </a:rPr>
-                        <a:t>Lai Kin Wah</a:t>
+                        <a:t>LAI KIN WAH</a:t>
                       </a:r>
                     </a:p>
                   </a:txBody>
@@ -4076,7 +4076,7 @@
                           </a:solidFill>
                           <a:latin typeface="Calibri"/>
                         </a:rPr>
-                        <a:t>KhoonSeng</a:t>
+                        <a:t>LIM KHOON SENG</a:t>
                       </a:r>
                     </a:p>
                   </a:txBody>
@@ -4156,7 +4156,7 @@
                 </a:solidFill>
                 <a:latin typeface="Calibri"/>
               </a:rPr>
-              <a:t>Joyce Yeo:  2 areas as Primary  +  2 areas as Secondary</a:t>
+              <a:t>YEO XIU JUAN:  2 areas as Primary  +  2 areas as Secondary</a:t>
             </a:r>
           </a:p>
         </p:txBody>
@@ -4191,7 +4191,7 @@
                 </a:solidFill>
                 <a:latin typeface="Calibri"/>
               </a:rPr>
-              <a:t>KhoonSeng:  2 areas as Primary  +  2 areas as Secondary</a:t>
+              <a:t>LIM KHOON SENG:  2 areas as Primary  +  2 areas as Secondary</a:t>
             </a:r>
           </a:p>
         </p:txBody>
@@ -4226,7 +4226,7 @@
                 </a:solidFill>
                 <a:latin typeface="Calibri"/>
               </a:rPr>
-              <a:t>Lai Kin Wah:  2 areas as Primary  +  2 areas as Secondary</a:t>
+              <a:t>LAI KIN WAH:  2 areas as Primary  +  2 areas as Secondary</a:t>
             </a:r>
           </a:p>
         </p:txBody>

</xml_diff>

<commit_message>
De-tech slides: pipeline box-flow, fix S2/S7, fixed contributions + IDs
- S4: replace ASCII monospace tree with 3-box visual flow (BEFORE SPLIT → 80/20 SPLIT → INSIDE PIPELINE)
- S2: remove param dump from exec summary; plain-language tuning bullet
- S7: drop n_jobs row and clone().fit() code snippet; plain refit line
- S10: fixed contribution matrix (no random seed); separate name/ID table; remove balance-check
- S1: name format → NAME (ID: XXXXXXX)
- Student IDs added: YEO XIU JUAN 2570777, LIM KHOON SENG 2570888, LAI KIN WAH 2570999 (dummy)

Co-Authored-By: Claude Sonnet 4.6 <noreply@anthropic.com>
</commit_message>
<xml_diff>
--- a/Week 1/Wk1_Capstone/group3.pptx
+++ b/Week 1/Wk1_Capstone/group3.pptx
@@ -3283,7 +3283,7 @@
                 </a:solidFill>
                 <a:latin typeface="Calibri"/>
               </a:rPr>
-              <a:t>  YEO XIU JUAN</a:t>
+              <a:t>  YEO XIU JUAN (ID: 2570777)</a:t>
             </a:r>
           </a:p>
         </p:txBody>
@@ -3318,7 +3318,7 @@
                 </a:solidFill>
                 <a:latin typeface="Calibri"/>
               </a:rPr>
-              <a:t>  LIM KHOON SENG</a:t>
+              <a:t>  LIM KHOON SENG (ID: 2570888)</a:t>
             </a:r>
           </a:p>
         </p:txBody>
@@ -3353,7 +3353,7 @@
                 </a:solidFill>
                 <a:latin typeface="Calibri"/>
               </a:rPr>
-              <a:t>  LAI KIN WAH</a:t>
+              <a:t>  LAI KIN WAH (ID: 2570999)</a:t>
             </a:r>
           </a:p>
         </p:txBody>
@@ -3532,41 +3532,224 @@
           </a:p>
         </p:txBody>
       </p:sp>
-      <p:sp>
-        <p:nvSpPr>
-          <p:cNvPr id="4" name="TextBox 3"/>
-          <p:cNvSpPr txBox="1"/>
+      <p:graphicFrame>
+        <p:nvGraphicFramePr>
+          <p:cNvPr id="4" name="Table 3"/>
+          <p:cNvGraphicFramePr>
+            <a:graphicFrameLocks noGrp="1"/>
+          </p:cNvGraphicFramePr>
           <p:nvPr/>
-        </p:nvSpPr>
-        <p:spPr>
-          <a:xfrm>
-            <a:off x="411480" y="658368"/>
-            <a:ext cx="11368735" cy="274320"/>
-          </a:xfrm>
-          <a:prstGeom prst="rect">
-            <a:avLst/>
-          </a:prstGeom>
-          <a:noFill/>
-        </p:spPr>
-        <p:txBody>
-          <a:bodyPr wrap="square">
-            <a:spAutoFit/>
-          </a:bodyPr>
-          <a:lstStyle/>
-          <a:p>
-            <a:pPr algn="l"/>
-            <a:r>
-              <a:rPr sz="1000" b="0" i="1">
-                <a:solidFill>
-                  <a:srgbClr val="7F8C8D"/>
-                </a:solidFill>
-                <a:latin typeface="Calibri"/>
-              </a:rPr>
-              <a:t>Balanced primary/secondary split  |  seed=42 (change CONTRIB_SEED to re-roll)</a:t>
-            </a:r>
-          </a:p>
-        </p:txBody>
-      </p:sp>
+        </p:nvGraphicFramePr>
+        <p:xfrm>
+          <a:off x="411480" y="749808"/>
+          <a:ext cx="4114800" cy="1243584"/>
+        </p:xfrm>
+        <a:graphic>
+          <a:graphicData uri="http://schemas.openxmlformats.org/drawingml/2006/table">
+            <a:tbl>
+              <a:tblPr firstRow="1" bandRow="1">
+                <a:tableStyleId>{5C22544A-7EE6-4342-B048-85BDC9FD1C3A}</a:tableStyleId>
+              </a:tblPr>
+              <a:tblGrid>
+                <a:gridCol w="2743200"/>
+                <a:gridCol w="1371600"/>
+              </a:tblGrid>
+              <a:tr h="310896">
+                <a:tc>
+                  <a:txBody>
+                    <a:bodyPr/>
+                    <a:lstStyle/>
+                    <a:p>
+                      <a:pPr algn="ctr"/>
+                      <a:r>
+                        <a:rPr sz="1100" b="1">
+                          <a:solidFill>
+                            <a:srgbClr val="FFFFFF"/>
+                          </a:solidFill>
+                          <a:latin typeface="Calibri"/>
+                        </a:rPr>
+                        <a:t>Name</a:t>
+                      </a:r>
+                    </a:p>
+                  </a:txBody>
+                  <a:tcPr>
+                    <a:solidFill>
+                      <a:srgbClr val="2980B9"/>
+                    </a:solidFill>
+                  </a:tcPr>
+                </a:tc>
+                <a:tc>
+                  <a:txBody>
+                    <a:bodyPr/>
+                    <a:lstStyle/>
+                    <a:p>
+                      <a:pPr algn="ctr"/>
+                      <a:r>
+                        <a:rPr sz="1100" b="1">
+                          <a:solidFill>
+                            <a:srgbClr val="FFFFFF"/>
+                          </a:solidFill>
+                          <a:latin typeface="Calibri"/>
+                        </a:rPr>
+                        <a:t>Student ID</a:t>
+                      </a:r>
+                    </a:p>
+                  </a:txBody>
+                  <a:tcPr>
+                    <a:solidFill>
+                      <a:srgbClr val="2980B9"/>
+                    </a:solidFill>
+                  </a:tcPr>
+                </a:tc>
+              </a:tr>
+              <a:tr h="310896">
+                <a:tc>
+                  <a:txBody>
+                    <a:bodyPr/>
+                    <a:lstStyle/>
+                    <a:p>
+                      <a:pPr algn="l"/>
+                      <a:r>
+                        <a:rPr sz="1000">
+                          <a:solidFill>
+                            <a:srgbClr val="2C3E50"/>
+                          </a:solidFill>
+                          <a:latin typeface="Calibri"/>
+                        </a:rPr>
+                        <a:t>YEO XIU JUAN</a:t>
+                      </a:r>
+                    </a:p>
+                  </a:txBody>
+                  <a:tcPr>
+                    <a:solidFill>
+                      <a:srgbClr val="EBF5FB"/>
+                    </a:solidFill>
+                  </a:tcPr>
+                </a:tc>
+                <a:tc>
+                  <a:txBody>
+                    <a:bodyPr/>
+                    <a:lstStyle/>
+                    <a:p>
+                      <a:pPr algn="ctr"/>
+                      <a:r>
+                        <a:rPr sz="1000">
+                          <a:solidFill>
+                            <a:srgbClr val="2C3E50"/>
+                          </a:solidFill>
+                          <a:latin typeface="Calibri"/>
+                        </a:rPr>
+                        <a:t>2570777</a:t>
+                      </a:r>
+                    </a:p>
+                  </a:txBody>
+                  <a:tcPr>
+                    <a:solidFill>
+                      <a:srgbClr val="EBF5FB"/>
+                    </a:solidFill>
+                  </a:tcPr>
+                </a:tc>
+              </a:tr>
+              <a:tr h="310896">
+                <a:tc>
+                  <a:txBody>
+                    <a:bodyPr/>
+                    <a:lstStyle/>
+                    <a:p>
+                      <a:pPr algn="l"/>
+                      <a:r>
+                        <a:rPr sz="1000">
+                          <a:solidFill>
+                            <a:srgbClr val="2C3E50"/>
+                          </a:solidFill>
+                          <a:latin typeface="Calibri"/>
+                        </a:rPr>
+                        <a:t>LIM KHOON SENG</a:t>
+                      </a:r>
+                    </a:p>
+                  </a:txBody>
+                  <a:tcPr>
+                    <a:solidFill>
+                      <a:srgbClr val="FFFFFF"/>
+                    </a:solidFill>
+                  </a:tcPr>
+                </a:tc>
+                <a:tc>
+                  <a:txBody>
+                    <a:bodyPr/>
+                    <a:lstStyle/>
+                    <a:p>
+                      <a:pPr algn="ctr"/>
+                      <a:r>
+                        <a:rPr sz="1000">
+                          <a:solidFill>
+                            <a:srgbClr val="2C3E50"/>
+                          </a:solidFill>
+                          <a:latin typeface="Calibri"/>
+                        </a:rPr>
+                        <a:t>2570888</a:t>
+                      </a:r>
+                    </a:p>
+                  </a:txBody>
+                  <a:tcPr>
+                    <a:solidFill>
+                      <a:srgbClr val="FFFFFF"/>
+                    </a:solidFill>
+                  </a:tcPr>
+                </a:tc>
+              </a:tr>
+              <a:tr h="310896">
+                <a:tc>
+                  <a:txBody>
+                    <a:bodyPr/>
+                    <a:lstStyle/>
+                    <a:p>
+                      <a:pPr algn="l"/>
+                      <a:r>
+                        <a:rPr sz="1000">
+                          <a:solidFill>
+                            <a:srgbClr val="2C3E50"/>
+                          </a:solidFill>
+                          <a:latin typeface="Calibri"/>
+                        </a:rPr>
+                        <a:t>LAI KIN WAH</a:t>
+                      </a:r>
+                    </a:p>
+                  </a:txBody>
+                  <a:tcPr>
+                    <a:solidFill>
+                      <a:srgbClr val="EBF5FB"/>
+                    </a:solidFill>
+                  </a:tcPr>
+                </a:tc>
+                <a:tc>
+                  <a:txBody>
+                    <a:bodyPr/>
+                    <a:lstStyle/>
+                    <a:p>
+                      <a:pPr algn="ctr"/>
+                      <a:r>
+                        <a:rPr sz="1000">
+                          <a:solidFill>
+                            <a:srgbClr val="2C3E50"/>
+                          </a:solidFill>
+                          <a:latin typeface="Calibri"/>
+                        </a:rPr>
+                        <a:t>2570999</a:t>
+                      </a:r>
+                    </a:p>
+                  </a:txBody>
+                  <a:tcPr>
+                    <a:solidFill>
+                      <a:srgbClr val="EBF5FB"/>
+                    </a:solidFill>
+                  </a:tcPr>
+                </a:tc>
+              </a:tr>
+            </a:tbl>
+          </a:graphicData>
+        </a:graphic>
+      </p:graphicFrame>
       <p:graphicFrame>
         <p:nvGraphicFramePr>
           <p:cNvPr id="5" name="Table 4"/>
@@ -3576,7 +3759,7 @@
           <p:nvPr/>
         </p:nvGraphicFramePr>
         <p:xfrm>
-          <a:off x="411480" y="1042416"/>
+          <a:off x="411480" y="2212848"/>
           <a:ext cx="10515600" cy="2176272"/>
         </p:xfrm>
         <a:graphic>
@@ -3840,7 +4023,7 @@
                           </a:solidFill>
                           <a:latin typeface="Calibri"/>
                         </a:rPr>
-                        <a:t>LAI KIN WAH</a:t>
+                        <a:t>YEO XIU JUAN</a:t>
                       </a:r>
                     </a:p>
                   </a:txBody>
@@ -4091,146 +4274,6 @@
           </a:graphicData>
         </a:graphic>
       </p:graphicFrame>
-      <p:sp>
-        <p:nvSpPr>
-          <p:cNvPr id="6" name="TextBox 5"/>
-          <p:cNvSpPr txBox="1"/>
-          <p:nvPr/>
-        </p:nvSpPr>
-        <p:spPr>
-          <a:xfrm>
-            <a:off x="411480" y="3602736"/>
-            <a:ext cx="11368735" cy="320040"/>
-          </a:xfrm>
-          <a:prstGeom prst="rect">
-            <a:avLst/>
-          </a:prstGeom>
-          <a:noFill/>
-        </p:spPr>
-        <p:txBody>
-          <a:bodyPr wrap="square">
-            <a:spAutoFit/>
-          </a:bodyPr>
-          <a:lstStyle/>
-          <a:p>
-            <a:pPr algn="l"/>
-            <a:r>
-              <a:rPr sz="1100" b="1" i="0">
-                <a:solidFill>
-                  <a:srgbClr val="7F8C8D"/>
-                </a:solidFill>
-                <a:latin typeface="Calibri"/>
-              </a:rPr>
-              <a:t>Balance check:</a:t>
-            </a:r>
-          </a:p>
-        </p:txBody>
-      </p:sp>
-      <p:sp>
-        <p:nvSpPr>
-          <p:cNvPr id="7" name="TextBox 6"/>
-          <p:cNvSpPr txBox="1"/>
-          <p:nvPr/>
-        </p:nvSpPr>
-        <p:spPr>
-          <a:xfrm>
-            <a:off x="411480" y="3922776"/>
-            <a:ext cx="11368735" cy="274320"/>
-          </a:xfrm>
-          <a:prstGeom prst="rect">
-            <a:avLst/>
-          </a:prstGeom>
-          <a:noFill/>
-        </p:spPr>
-        <p:txBody>
-          <a:bodyPr wrap="square">
-            <a:spAutoFit/>
-          </a:bodyPr>
-          <a:lstStyle/>
-          <a:p>
-            <a:pPr algn="l"/>
-            <a:r>
-              <a:rPr sz="1100" b="0" i="0">
-                <a:solidFill>
-                  <a:srgbClr val="2C3E50"/>
-                </a:solidFill>
-                <a:latin typeface="Calibri"/>
-              </a:rPr>
-              <a:t>YEO XIU JUAN:  2 areas as Primary  +  2 areas as Secondary</a:t>
-            </a:r>
-          </a:p>
-        </p:txBody>
-      </p:sp>
-      <p:sp>
-        <p:nvSpPr>
-          <p:cNvPr id="8" name="TextBox 7"/>
-          <p:cNvSpPr txBox="1"/>
-          <p:nvPr/>
-        </p:nvSpPr>
-        <p:spPr>
-          <a:xfrm>
-            <a:off x="411480" y="4197095"/>
-            <a:ext cx="11368735" cy="274320"/>
-          </a:xfrm>
-          <a:prstGeom prst="rect">
-            <a:avLst/>
-          </a:prstGeom>
-          <a:noFill/>
-        </p:spPr>
-        <p:txBody>
-          <a:bodyPr wrap="square">
-            <a:spAutoFit/>
-          </a:bodyPr>
-          <a:lstStyle/>
-          <a:p>
-            <a:pPr algn="l"/>
-            <a:r>
-              <a:rPr sz="1100" b="0" i="0">
-                <a:solidFill>
-                  <a:srgbClr val="2C3E50"/>
-                </a:solidFill>
-                <a:latin typeface="Calibri"/>
-              </a:rPr>
-              <a:t>LIM KHOON SENG:  2 areas as Primary  +  2 areas as Secondary</a:t>
-            </a:r>
-          </a:p>
-        </p:txBody>
-      </p:sp>
-      <p:sp>
-        <p:nvSpPr>
-          <p:cNvPr id="9" name="TextBox 8"/>
-          <p:cNvSpPr txBox="1"/>
-          <p:nvPr/>
-        </p:nvSpPr>
-        <p:spPr>
-          <a:xfrm>
-            <a:off x="411480" y="4471416"/>
-            <a:ext cx="11368735" cy="274320"/>
-          </a:xfrm>
-          <a:prstGeom prst="rect">
-            <a:avLst/>
-          </a:prstGeom>
-          <a:noFill/>
-        </p:spPr>
-        <p:txBody>
-          <a:bodyPr wrap="square">
-            <a:spAutoFit/>
-          </a:bodyPr>
-          <a:lstStyle/>
-          <a:p>
-            <a:pPr algn="l"/>
-            <a:r>
-              <a:rPr sz="1100" b="0" i="0">
-                <a:solidFill>
-                  <a:srgbClr val="2C3E50"/>
-                </a:solidFill>
-                <a:latin typeface="Calibri"/>
-              </a:rPr>
-              <a:t>LAI KIN WAH:  2 areas as Primary  +  2 areas as Secondary</a:t>
-            </a:r>
-          </a:p>
-        </p:txBody>
-      </p:sp>
     </p:spTree>
   </p:cSld>
   <p:clrMapOvr>
@@ -4417,7 +4460,7 @@
                 </a:solidFill>
                 <a:latin typeface="Calibri"/>
               </a:rPr>
-              <a:t>◆  GridSearchCV tuning on champion only: best params → learning_rate=0.05, max_depth=3, n_estimators=400</a:t>
+              <a:t>◆  Champion tuned via GridSearchCV (champion-only, ≤50-config budget); CV ROC-AUC 0.9104±0.0014</a:t>
             </a:r>
           </a:p>
           <a:p>
@@ -4935,7 +4978,85 @@
         <p:spPr>
           <a:xfrm>
             <a:off x="411480" y="1042416"/>
-            <a:ext cx="11368735" cy="1965960"/>
+            <a:ext cx="2560320" cy="347472"/>
+          </a:xfrm>
+          <a:prstGeom prst="rect">
+            <a:avLst/>
+          </a:prstGeom>
+          <a:solidFill>
+            <a:srgbClr val="2980B9"/>
+          </a:solidFill>
+          <a:ln>
+            <a:noFill/>
+          </a:ln>
+        </p:spPr>
+        <p:style>
+          <a:lnRef idx="1">
+            <a:schemeClr val="accent1"/>
+          </a:lnRef>
+          <a:fillRef idx="3">
+            <a:schemeClr val="accent1"/>
+          </a:fillRef>
+          <a:effectRef idx="2">
+            <a:schemeClr val="accent1"/>
+          </a:effectRef>
+          <a:fontRef idx="minor">
+            <a:schemeClr val="lt1"/>
+          </a:fontRef>
+        </p:style>
+        <p:txBody>
+          <a:bodyPr rtlCol="0" anchor="ctr"/>
+          <a:lstStyle/>
+          <a:p>
+            <a:pPr algn="ctr"/>
+          </a:p>
+        </p:txBody>
+      </p:sp>
+      <p:sp>
+        <p:nvSpPr>
+          <p:cNvPr id="6" name="TextBox 5"/>
+          <p:cNvSpPr txBox="1"/>
+          <p:nvPr/>
+        </p:nvSpPr>
+        <p:spPr>
+          <a:xfrm>
+            <a:off x="484632" y="1097280"/>
+            <a:ext cx="2468880" cy="274320"/>
+          </a:xfrm>
+          <a:prstGeom prst="rect">
+            <a:avLst/>
+          </a:prstGeom>
+          <a:noFill/>
+        </p:spPr>
+        <p:txBody>
+          <a:bodyPr wrap="square">
+            <a:spAutoFit/>
+          </a:bodyPr>
+          <a:lstStyle/>
+          <a:p>
+            <a:pPr algn="l"/>
+            <a:r>
+              <a:rPr sz="1100" b="1" i="0">
+                <a:solidFill>
+                  <a:srgbClr val="FFFFFF"/>
+                </a:solidFill>
+                <a:latin typeface="Calibri"/>
+              </a:rPr>
+              <a:t>BEFORE SPLIT</a:t>
+            </a:r>
+          </a:p>
+        </p:txBody>
+      </p:sp>
+      <p:sp>
+        <p:nvSpPr>
+          <p:cNvPr id="7" name="Rectangle 6"/>
+          <p:cNvSpPr/>
+          <p:nvPr/>
+        </p:nvSpPr>
+        <p:spPr>
+          <a:xfrm>
+            <a:off x="411480" y="1389888"/>
+            <a:ext cx="2560320" cy="1664208"/>
           </a:xfrm>
           <a:prstGeom prst="rect">
             <a:avLst/>
@@ -4971,14 +5092,14 @@
       </p:sp>
       <p:sp>
         <p:nvSpPr>
-          <p:cNvPr id="6" name="TextBox 5"/>
+          <p:cNvPr id="8" name="TextBox 7"/>
           <p:cNvSpPr txBox="1"/>
           <p:nvPr/>
         </p:nvSpPr>
         <p:spPr>
           <a:xfrm>
-            <a:off x="548640" y="1133856"/>
-            <a:ext cx="11094415" cy="1828800"/>
+            <a:off x="484632" y="1481328"/>
+            <a:ext cx="2450592" cy="1508760"/>
           </a:xfrm>
           <a:prstGeom prst="rect">
             <a:avLst/>
@@ -4986,117 +5107,539 @@
           <a:noFill/>
         </p:spPr>
         <p:txBody>
-          <a:bodyPr wrap="none">
+          <a:bodyPr wrap="square">
             <a:spAutoFit/>
           </a:bodyPr>
           <a:lstStyle/>
           <a:p>
-            <a:pPr>
+            <a:pPr algn="l">
               <a:spcBef>
-                <a:spcPts val="200"/>
+                <a:spcPts val="300"/>
               </a:spcBef>
             </a:pPr>
             <a:r>
-              <a:rPr sz="1300">
+              <a:rPr sz="1100">
                 <a:solidFill>
                   <a:srgbClr val="2C3E50"/>
                 </a:solidFill>
-                <a:latin typeface="Courier New"/>
+                <a:latin typeface="Calibri"/>
               </a:rPr>
-              <a:t>ImbPipeline</a:t>
-            </a:r>
-          </a:p>
-          <a:p>
-            <a:pPr>
+              <a:t>•  Coerce TotalCharges to numeric</a:t>
+            </a:r>
+          </a:p>
+          <a:p>
+            <a:pPr algn="l">
               <a:spcBef>
-                <a:spcPts val="200"/>
+                <a:spcPts val="300"/>
               </a:spcBef>
             </a:pPr>
             <a:r>
-              <a:rPr sz="1300">
+              <a:rPr sz="1100">
                 <a:solidFill>
                   <a:srgbClr val="2C3E50"/>
                 </a:solidFill>
-                <a:latin typeface="Courier New"/>
+                <a:latin typeface="Calibri"/>
               </a:rPr>
-              <a:t>  ├── preprocessor  (ColumnTransformer)</a:t>
-            </a:r>
-          </a:p>
-          <a:p>
-            <a:pPr>
+              <a:t>•  Map target: Yes → 1, No → 0</a:t>
+            </a:r>
+          </a:p>
+          <a:p>
+            <a:pPr algn="l">
               <a:spcBef>
-                <a:spcPts val="200"/>
+                <a:spcPts val="300"/>
               </a:spcBef>
             </a:pPr>
             <a:r>
-              <a:rPr sz="1300">
+              <a:rPr sz="1100">
                 <a:solidFill>
                   <a:srgbClr val="2C3E50"/>
                 </a:solidFill>
-                <a:latin typeface="Courier New"/>
+                <a:latin typeface="Calibri"/>
               </a:rPr>
-              <a:t>  │     ├── num_pipe  :  StandardScaler</a:t>
-            </a:r>
-          </a:p>
-          <a:p>
-            <a:pPr>
+              <a:t>•  Drop ID column</a:t>
+            </a:r>
+          </a:p>
+        </p:txBody>
+      </p:sp>
+      <p:sp>
+        <p:nvSpPr>
+          <p:cNvPr id="9" name="TextBox 8"/>
+          <p:cNvSpPr txBox="1"/>
+          <p:nvPr/>
+        </p:nvSpPr>
+        <p:spPr>
+          <a:xfrm>
+            <a:off x="2971800" y="1847088"/>
+            <a:ext cx="411480" cy="365760"/>
+          </a:xfrm>
+          <a:prstGeom prst="rect">
+            <a:avLst/>
+          </a:prstGeom>
+          <a:noFill/>
+        </p:spPr>
+        <p:txBody>
+          <a:bodyPr wrap="square">
+            <a:spAutoFit/>
+          </a:bodyPr>
+          <a:lstStyle/>
+          <a:p>
+            <a:pPr algn="ctr"/>
+            <a:r>
+              <a:rPr sz="2000" b="1" i="0">
+                <a:solidFill>
+                  <a:srgbClr val="2980B9"/>
+                </a:solidFill>
+                <a:latin typeface="Calibri"/>
+              </a:rPr>
+              <a:t>→</a:t>
+            </a:r>
+          </a:p>
+        </p:txBody>
+      </p:sp>
+      <p:sp>
+        <p:nvSpPr>
+          <p:cNvPr id="10" name="Rectangle 9"/>
+          <p:cNvSpPr/>
+          <p:nvPr/>
+        </p:nvSpPr>
+        <p:spPr>
+          <a:xfrm>
+            <a:off x="3383280" y="1042416"/>
+            <a:ext cx="2011680" cy="347472"/>
+          </a:xfrm>
+          <a:prstGeom prst="rect">
+            <a:avLst/>
+          </a:prstGeom>
+          <a:solidFill>
+            <a:srgbClr val="2980B9"/>
+          </a:solidFill>
+          <a:ln>
+            <a:noFill/>
+          </a:ln>
+        </p:spPr>
+        <p:style>
+          <a:lnRef idx="1">
+            <a:schemeClr val="accent1"/>
+          </a:lnRef>
+          <a:fillRef idx="3">
+            <a:schemeClr val="accent1"/>
+          </a:fillRef>
+          <a:effectRef idx="2">
+            <a:schemeClr val="accent1"/>
+          </a:effectRef>
+          <a:fontRef idx="minor">
+            <a:schemeClr val="lt1"/>
+          </a:fontRef>
+        </p:style>
+        <p:txBody>
+          <a:bodyPr rtlCol="0" anchor="ctr"/>
+          <a:lstStyle/>
+          <a:p>
+            <a:pPr algn="ctr"/>
+          </a:p>
+        </p:txBody>
+      </p:sp>
+      <p:sp>
+        <p:nvSpPr>
+          <p:cNvPr id="11" name="TextBox 10"/>
+          <p:cNvSpPr txBox="1"/>
+          <p:nvPr/>
+        </p:nvSpPr>
+        <p:spPr>
+          <a:xfrm>
+            <a:off x="3456432" y="1097280"/>
+            <a:ext cx="1920240" cy="274320"/>
+          </a:xfrm>
+          <a:prstGeom prst="rect">
+            <a:avLst/>
+          </a:prstGeom>
+          <a:noFill/>
+        </p:spPr>
+        <p:txBody>
+          <a:bodyPr wrap="square">
+            <a:spAutoFit/>
+          </a:bodyPr>
+          <a:lstStyle/>
+          <a:p>
+            <a:pPr algn="l"/>
+            <a:r>
+              <a:rPr sz="1100" b="1" i="0">
+                <a:solidFill>
+                  <a:srgbClr val="FFFFFF"/>
+                </a:solidFill>
+                <a:latin typeface="Calibri"/>
+              </a:rPr>
+              <a:t>80 / 20 SPLIT</a:t>
+            </a:r>
+          </a:p>
+        </p:txBody>
+      </p:sp>
+      <p:sp>
+        <p:nvSpPr>
+          <p:cNvPr id="12" name="Rectangle 11"/>
+          <p:cNvSpPr/>
+          <p:nvPr/>
+        </p:nvSpPr>
+        <p:spPr>
+          <a:xfrm>
+            <a:off x="3383280" y="1389888"/>
+            <a:ext cx="2011680" cy="1664208"/>
+          </a:xfrm>
+          <a:prstGeom prst="rect">
+            <a:avLst/>
+          </a:prstGeom>
+          <a:solidFill>
+            <a:srgbClr val="EBF5FB"/>
+          </a:solidFill>
+          <a:ln>
+            <a:noFill/>
+          </a:ln>
+        </p:spPr>
+        <p:style>
+          <a:lnRef idx="1">
+            <a:schemeClr val="accent1"/>
+          </a:lnRef>
+          <a:fillRef idx="3">
+            <a:schemeClr val="accent1"/>
+          </a:fillRef>
+          <a:effectRef idx="2">
+            <a:schemeClr val="accent1"/>
+          </a:effectRef>
+          <a:fontRef idx="minor">
+            <a:schemeClr val="lt1"/>
+          </a:fontRef>
+        </p:style>
+        <p:txBody>
+          <a:bodyPr rtlCol="0" anchor="ctr"/>
+          <a:lstStyle/>
+          <a:p>
+            <a:pPr algn="ctr"/>
+          </a:p>
+        </p:txBody>
+      </p:sp>
+      <p:sp>
+        <p:nvSpPr>
+          <p:cNvPr id="13" name="TextBox 12"/>
+          <p:cNvSpPr txBox="1"/>
+          <p:nvPr/>
+        </p:nvSpPr>
+        <p:spPr>
+          <a:xfrm>
+            <a:off x="3456432" y="1481328"/>
+            <a:ext cx="1901952" cy="1508760"/>
+          </a:xfrm>
+          <a:prstGeom prst="rect">
+            <a:avLst/>
+          </a:prstGeom>
+          <a:noFill/>
+        </p:spPr>
+        <p:txBody>
+          <a:bodyPr wrap="square">
+            <a:spAutoFit/>
+          </a:bodyPr>
+          <a:lstStyle/>
+          <a:p>
+            <a:pPr algn="l">
               <a:spcBef>
-                <a:spcPts val="200"/>
+                <a:spcPts val="300"/>
               </a:spcBef>
             </a:pPr>
             <a:r>
-              <a:rPr sz="1300">
+              <a:rPr sz="1100">
                 <a:solidFill>
                   <a:srgbClr val="2C3E50"/>
                 </a:solidFill>
-                <a:latin typeface="Courier New"/>
+                <a:latin typeface="Calibri"/>
               </a:rPr>
-              <a:t>  │     └── cat_pipe  :  OneHotEncoder  →  SelectPercentile(chi², 50%)</a:t>
-            </a:r>
-          </a:p>
-          <a:p>
-            <a:pPr>
+              <a:t>•  Stratified by Churn</a:t>
+            </a:r>
+          </a:p>
+          <a:p>
+            <a:pPr algn="l">
               <a:spcBef>
-                <a:spcPts val="200"/>
+                <a:spcPts val="300"/>
               </a:spcBef>
             </a:pPr>
             <a:r>
-              <a:rPr sz="1300">
+              <a:rPr sz="1100">
                 <a:solidFill>
                   <a:srgbClr val="2C3E50"/>
                 </a:solidFill>
-                <a:latin typeface="Courier New"/>
+                <a:latin typeface="Calibri"/>
               </a:rPr>
-              <a:t>  ├── smote          :  SMOTE(random_state=42)   ← training fold only</a:t>
-            </a:r>
-          </a:p>
-          <a:p>
-            <a:pPr>
+              <a:t>•  Seed = 42</a:t>
+            </a:r>
+          </a:p>
+          <a:p>
+            <a:pPr algn="l">
               <a:spcBef>
-                <a:spcPts val="200"/>
+                <a:spcPts val="300"/>
               </a:spcBef>
             </a:pPr>
             <a:r>
-              <a:rPr sz="1300">
+              <a:rPr sz="1100">
                 <a:solidFill>
                   <a:srgbClr val="2C3E50"/>
                 </a:solidFill>
-                <a:latin typeface="Courier New"/>
+                <a:latin typeface="Calibri"/>
               </a:rPr>
-              <a:t>  └── classifier     :  &lt;champion&gt;</a:t>
-            </a:r>
-          </a:p>
-        </p:txBody>
-      </p:sp>
-      <p:sp>
-        <p:nvSpPr>
-          <p:cNvPr id="7" name="TextBox 6"/>
+              <a:t>•  Test set locked until §4</a:t>
+            </a:r>
+          </a:p>
+        </p:txBody>
+      </p:sp>
+      <p:sp>
+        <p:nvSpPr>
+          <p:cNvPr id="14" name="TextBox 13"/>
           <p:cNvSpPr txBox="1"/>
           <p:nvPr/>
         </p:nvSpPr>
         <p:spPr>
           <a:xfrm>
-            <a:off x="411480" y="3191256"/>
+            <a:off x="5394960" y="1847088"/>
+            <a:ext cx="411480" cy="365760"/>
+          </a:xfrm>
+          <a:prstGeom prst="rect">
+            <a:avLst/>
+          </a:prstGeom>
+          <a:noFill/>
+        </p:spPr>
+        <p:txBody>
+          <a:bodyPr wrap="square">
+            <a:spAutoFit/>
+          </a:bodyPr>
+          <a:lstStyle/>
+          <a:p>
+            <a:pPr algn="ctr"/>
+            <a:r>
+              <a:rPr sz="2000" b="1" i="0">
+                <a:solidFill>
+                  <a:srgbClr val="2980B9"/>
+                </a:solidFill>
+                <a:latin typeface="Calibri"/>
+              </a:rPr>
+              <a:t>→</a:t>
+            </a:r>
+          </a:p>
+        </p:txBody>
+      </p:sp>
+      <p:sp>
+        <p:nvSpPr>
+          <p:cNvPr id="15" name="Rectangle 14"/>
+          <p:cNvSpPr/>
+          <p:nvPr/>
+        </p:nvSpPr>
+        <p:spPr>
+          <a:xfrm>
+            <a:off x="5806440" y="1042416"/>
+            <a:ext cx="5973775" cy="347472"/>
+          </a:xfrm>
+          <a:prstGeom prst="rect">
+            <a:avLst/>
+          </a:prstGeom>
+          <a:solidFill>
+            <a:srgbClr val="1A5676"/>
+          </a:solidFill>
+          <a:ln>
+            <a:noFill/>
+          </a:ln>
+        </p:spPr>
+        <p:style>
+          <a:lnRef idx="1">
+            <a:schemeClr val="accent1"/>
+          </a:lnRef>
+          <a:fillRef idx="3">
+            <a:schemeClr val="accent1"/>
+          </a:fillRef>
+          <a:effectRef idx="2">
+            <a:schemeClr val="accent1"/>
+          </a:effectRef>
+          <a:fontRef idx="minor">
+            <a:schemeClr val="lt1"/>
+          </a:fontRef>
+        </p:style>
+        <p:txBody>
+          <a:bodyPr rtlCol="0" anchor="ctr"/>
+          <a:lstStyle/>
+          <a:p>
+            <a:pPr algn="ctr"/>
+          </a:p>
+        </p:txBody>
+      </p:sp>
+      <p:sp>
+        <p:nvSpPr>
+          <p:cNvPr id="16" name="TextBox 15"/>
+          <p:cNvSpPr txBox="1"/>
+          <p:nvPr/>
+        </p:nvSpPr>
+        <p:spPr>
+          <a:xfrm>
+            <a:off x="5879592" y="1097280"/>
+            <a:ext cx="5882335" cy="274320"/>
+          </a:xfrm>
+          <a:prstGeom prst="rect">
+            <a:avLst/>
+          </a:prstGeom>
+          <a:noFill/>
+        </p:spPr>
+        <p:txBody>
+          <a:bodyPr wrap="square">
+            <a:spAutoFit/>
+          </a:bodyPr>
+          <a:lstStyle/>
+          <a:p>
+            <a:pPr algn="l"/>
+            <a:r>
+              <a:rPr sz="1100" b="1" i="0">
+                <a:solidFill>
+                  <a:srgbClr val="FFFFFF"/>
+                </a:solidFill>
+                <a:latin typeface="Calibri"/>
+              </a:rPr>
+              <a:t>INSIDE PIPELINE  (per CV fold)</a:t>
+            </a:r>
+          </a:p>
+        </p:txBody>
+      </p:sp>
+      <p:sp>
+        <p:nvSpPr>
+          <p:cNvPr id="17" name="Rectangle 16"/>
+          <p:cNvSpPr/>
+          <p:nvPr/>
+        </p:nvSpPr>
+        <p:spPr>
+          <a:xfrm>
+            <a:off x="5806440" y="1389888"/>
+            <a:ext cx="5973775" cy="1664208"/>
+          </a:xfrm>
+          <a:prstGeom prst="rect">
+            <a:avLst/>
+          </a:prstGeom>
+          <a:solidFill>
+            <a:srgbClr val="EBF5FB"/>
+          </a:solidFill>
+          <a:ln>
+            <a:noFill/>
+          </a:ln>
+        </p:spPr>
+        <p:style>
+          <a:lnRef idx="1">
+            <a:schemeClr val="accent1"/>
+          </a:lnRef>
+          <a:fillRef idx="3">
+            <a:schemeClr val="accent1"/>
+          </a:fillRef>
+          <a:effectRef idx="2">
+            <a:schemeClr val="accent1"/>
+          </a:effectRef>
+          <a:fontRef idx="minor">
+            <a:schemeClr val="lt1"/>
+          </a:fontRef>
+        </p:style>
+        <p:txBody>
+          <a:bodyPr rtlCol="0" anchor="ctr"/>
+          <a:lstStyle/>
+          <a:p>
+            <a:pPr algn="ctr"/>
+          </a:p>
+        </p:txBody>
+      </p:sp>
+      <p:sp>
+        <p:nvSpPr>
+          <p:cNvPr id="18" name="TextBox 17"/>
+          <p:cNvSpPr txBox="1"/>
+          <p:nvPr/>
+        </p:nvSpPr>
+        <p:spPr>
+          <a:xfrm>
+            <a:off x="5879592" y="1481328"/>
+            <a:ext cx="5864047" cy="1508760"/>
+          </a:xfrm>
+          <a:prstGeom prst="rect">
+            <a:avLst/>
+          </a:prstGeom>
+          <a:noFill/>
+        </p:spPr>
+        <p:txBody>
+          <a:bodyPr wrap="square">
+            <a:spAutoFit/>
+          </a:bodyPr>
+          <a:lstStyle/>
+          <a:p>
+            <a:pPr algn="l">
+              <a:spcBef>
+                <a:spcPts val="300"/>
+              </a:spcBef>
+            </a:pPr>
+            <a:r>
+              <a:rPr sz="1200">
+                <a:solidFill>
+                  <a:srgbClr val="2C3E50"/>
+                </a:solidFill>
+                <a:latin typeface="Calibri"/>
+              </a:rPr>
+              <a:t>  Numeric  →  StandardScaler</a:t>
+            </a:r>
+          </a:p>
+          <a:p>
+            <a:pPr algn="l">
+              <a:spcBef>
+                <a:spcPts val="300"/>
+              </a:spcBef>
+            </a:pPr>
+            <a:r>
+              <a:rPr sz="1200">
+                <a:solidFill>
+                  <a:srgbClr val="2C3E50"/>
+                </a:solidFill>
+                <a:latin typeface="Calibri"/>
+              </a:rPr>
+              <a:t>  Categorical  →  OneHotEncoder  →  χ² top-50%</a:t>
+            </a:r>
+          </a:p>
+          <a:p>
+            <a:pPr algn="l">
+              <a:spcBef>
+                <a:spcPts val="300"/>
+              </a:spcBef>
+            </a:pPr>
+            <a:r>
+              <a:rPr sz="1200">
+                <a:solidFill>
+                  <a:srgbClr val="2C3E50"/>
+                </a:solidFill>
+                <a:latin typeface="Calibri"/>
+              </a:rPr>
+              <a:t>  ↓  SMOTE  (training fold only)</a:t>
+            </a:r>
+          </a:p>
+          <a:p>
+            <a:pPr algn="l">
+              <a:spcBef>
+                <a:spcPts val="300"/>
+              </a:spcBef>
+            </a:pPr>
+            <a:r>
+              <a:rPr sz="1200">
+                <a:solidFill>
+                  <a:srgbClr val="2C3E50"/>
+                </a:solidFill>
+                <a:latin typeface="Calibri"/>
+              </a:rPr>
+              <a:t>  ↓  XGBoost champion</a:t>
+            </a:r>
+          </a:p>
+        </p:txBody>
+      </p:sp>
+      <p:sp>
+        <p:nvSpPr>
+          <p:cNvPr id="19" name="TextBox 18"/>
+          <p:cNvSpPr txBox="1"/>
+          <p:nvPr/>
+        </p:nvSpPr>
+        <p:spPr>
+          <a:xfrm>
+            <a:off x="411480" y="3282696"/>
             <a:ext cx="11368735" cy="320040"/>
           </a:xfrm>
           <a:prstGeom prst="rect">
@@ -5125,14 +5668,14 @@
       </p:sp>
       <p:sp>
         <p:nvSpPr>
-          <p:cNvPr id="8" name="TextBox 7"/>
+          <p:cNvPr id="20" name="TextBox 19"/>
           <p:cNvSpPr txBox="1"/>
           <p:nvPr/>
         </p:nvSpPr>
         <p:spPr>
           <a:xfrm>
-            <a:off x="411480" y="3538728"/>
-            <a:ext cx="11368735" cy="3209544"/>
+            <a:off x="411480" y="3630168"/>
+            <a:ext cx="11368735" cy="3118104"/>
           </a:xfrm>
           <a:prstGeom prst="rect">
             <a:avLst/>
@@ -5157,7 +5700,7 @@
                 </a:solidFill>
                 <a:latin typeface="Calibri"/>
               </a:rPr>
-              <a:t>◆  SMOTE inside pipeline — oversampling applied only to training folds, never to validation data.</a:t>
+              <a:t>◆  SMOTE runs inside the pipeline — oversampling touches training folds only, never validation/test.</a:t>
             </a:r>
           </a:p>
           <a:p>
@@ -5173,7 +5716,7 @@
                 </a:solidFill>
                 <a:latin typeface="Calibri"/>
               </a:rPr>
-              <a:t>◆  SelectPercentile(chi², 50%) — retains top-50% of one-hot columns by χ² association with Churn.</a:t>
+              <a:t>◆  χ² feature selection keeps the top-50% of encoded categories most associated with churn.</a:t>
             </a:r>
           </a:p>
           <a:p>
@@ -5189,7 +5732,7 @@
                 </a:solidFill>
                 <a:latin typeface="Calibri"/>
               </a:rPr>
-              <a:t>◆  OneHotEncoder(handle_unknown='ignore') — unseen categories in test set silently zeroed.</a:t>
+              <a:t>◆  Numeric features scaled so Logistic Regression converges; trees are scale-invariant.</a:t>
             </a:r>
           </a:p>
           <a:p>
@@ -5205,23 +5748,7 @@
                 </a:solidFill>
                 <a:latin typeface="Calibri"/>
               </a:rPr>
-              <a:t>◆  StandardScaler on numeric features — required for Logistic Regression convergence.</a:t>
-            </a:r>
-          </a:p>
-          <a:p>
-            <a:pPr algn="l">
-              <a:spcBef>
-                <a:spcPts val="300"/>
-              </a:spcBef>
-            </a:pPr>
-            <a:r>
-              <a:rPr sz="1200">
-                <a:solidFill>
-                  <a:srgbClr val="2C3E50"/>
-                </a:solidFill>
-                <a:latin typeface="Calibri"/>
-              </a:rPr>
-              <a:t>◆  All transforms fit on training fold only; test fold transformed but never fitted.</a:t>
+              <a:t>◆  Every transform is fit on the training fold only — the test set is untouched until §4.</a:t>
             </a:r>
           </a:p>
         </p:txBody>
@@ -6626,7 +7153,7 @@
                 </a:solidFill>
                 <a:latin typeface="Calibri"/>
               </a:rPr>
-              <a:t>GridSearchCV on champion only  |  ≤50 candidate-config cap  |  n_jobs=2 (SMOTE memory)</a:t>
+              <a:t>GridSearchCV on champion only  |  ≤50 candidate-config cap</a:t>
             </a:r>
           </a:p>
         </p:txBody>
@@ -6641,7 +7168,7 @@
         </p:nvGraphicFramePr>
         <p:xfrm>
           <a:off x="411480" y="1042416"/>
-          <a:ext cx="6858000" cy="2487168"/>
+          <a:ext cx="6858000" cy="2176272"/>
         </p:xfrm>
         <a:graphic>
           <a:graphicData uri="http://schemas.openxmlformats.org/drawingml/2006/table">
@@ -7151,77 +7678,6 @@
                   </a:tcPr>
                 </a:tc>
               </a:tr>
-              <a:tr h="310896">
-                <a:tc>
-                  <a:txBody>
-                    <a:bodyPr/>
-                    <a:lstStyle/>
-                    <a:p>
-                      <a:pPr algn="l"/>
-                      <a:r>
-                        <a:rPr sz="1000">
-                          <a:solidFill>
-                            <a:srgbClr val="2C3E50"/>
-                          </a:solidFill>
-                          <a:latin typeface="Calibri"/>
-                        </a:rPr>
-                        <a:t>n_jobs</a:t>
-                      </a:r>
-                    </a:p>
-                  </a:txBody>
-                  <a:tcPr>
-                    <a:solidFill>
-                      <a:srgbClr val="EBF5FB"/>
-                    </a:solidFill>
-                  </a:tcPr>
-                </a:tc>
-                <a:tc>
-                  <a:txBody>
-                    <a:bodyPr/>
-                    <a:lstStyle/>
-                    <a:p>
-                      <a:pPr algn="ctr"/>
-                      <a:r>
-                        <a:rPr sz="1000">
-                          <a:solidFill>
-                            <a:srgbClr val="2C3E50"/>
-                          </a:solidFill>
-                          <a:latin typeface="Calibri"/>
-                        </a:rPr>
-                        <a:t>2</a:t>
-                      </a:r>
-                    </a:p>
-                  </a:txBody>
-                  <a:tcPr>
-                    <a:solidFill>
-                      <a:srgbClr val="EBF5FB"/>
-                    </a:solidFill>
-                  </a:tcPr>
-                </a:tc>
-                <a:tc>
-                  <a:txBody>
-                    <a:bodyPr/>
-                    <a:lstStyle/>
-                    <a:p>
-                      <a:pPr algn="ctr"/>
-                      <a:r>
-                        <a:rPr sz="1000">
-                          <a:solidFill>
-                            <a:srgbClr val="2C3E50"/>
-                          </a:solidFill>
-                          <a:latin typeface="Calibri"/>
-                        </a:rPr>
-                        <a:t>SMOTE in pipeline — -1 causes memory blow-up</a:t>
-                      </a:r>
-                    </a:p>
-                  </a:txBody>
-                  <a:tcPr>
-                    <a:solidFill>
-                      <a:srgbClr val="EBF5FB"/>
-                    </a:solidFill>
-                  </a:tcPr>
-                </a:tc>
-              </a:tr>
             </a:tbl>
           </a:graphicData>
         </a:graphic>
@@ -7278,7 +7734,7 @@
           <a:noFill/>
         </p:spPr>
         <p:txBody>
-          <a:bodyPr wrap="none">
+          <a:bodyPr wrap="square">
             <a:spAutoFit/>
           </a:bodyPr>
           <a:lstStyle/>
@@ -7293,7 +7749,7 @@
                 <a:solidFill>
                   <a:srgbClr val="2C3E50"/>
                 </a:solidFill>
-                <a:latin typeface="Courier New"/>
+                <a:latin typeface="Calibri"/>
               </a:rPr>
               <a:t>Champion:     XGBoost</a:t>
             </a:r>
@@ -7309,7 +7765,7 @@
                 <a:solidFill>
                   <a:srgbClr val="2C3E50"/>
                 </a:solidFill>
-                <a:latin typeface="Courier New"/>
+                <a:latin typeface="Calibri"/>
               </a:rPr>
               <a:t>Best params:  learning_rate=0.05, max_depth=3, n_estimators=400</a:t>
             </a:r>
@@ -7325,7 +7781,7 @@
                 <a:solidFill>
                   <a:srgbClr val="2C3E50"/>
                 </a:solidFill>
-                <a:latin typeface="Courier New"/>
+                <a:latin typeface="Calibri"/>
               </a:rPr>
               <a:t>CV ROC-AUC:  0.9104±0.0014</a:t>
             </a:r>
@@ -7341,7 +7797,7 @@
                 <a:solidFill>
                   <a:srgbClr val="2C3E50"/>
                 </a:solidFill>
-                <a:latin typeface="Courier New"/>
+                <a:latin typeface="Calibri"/>
               </a:rPr>
               <a:t>CV Recall:    0.8582±0.0032</a:t>
             </a:r>
@@ -7357,7 +7813,7 @@
                 <a:solidFill>
                   <a:srgbClr val="2C3E50"/>
                 </a:solidFill>
-                <a:latin typeface="Courier New"/>
+                <a:latin typeface="Calibri"/>
               </a:rPr>
               <a:t/>
             </a:r>
@@ -7373,41 +7829,9 @@
                 <a:solidFill>
                   <a:srgbClr val="2C3E50"/>
                 </a:solidFill>
-                <a:latin typeface="Courier New"/>
+                <a:latin typeface="Calibri"/>
               </a:rPr>
-              <a:t>Refit: clone(best_estimator_)</a:t>
-            </a:r>
-          </a:p>
-          <a:p>
-            <a:pPr>
-              <a:spcBef>
-                <a:spcPts val="300"/>
-              </a:spcBef>
-            </a:pPr>
-            <a:r>
-              <a:rPr sz="1200">
-                <a:solidFill>
-                  <a:srgbClr val="2C3E50"/>
-                </a:solidFill>
-                <a:latin typeface="Courier New"/>
-              </a:rPr>
-              <a:t>       .fit(X_train, y_train)</a:t>
-            </a:r>
-          </a:p>
-          <a:p>
-            <a:pPr>
-              <a:spcBef>
-                <a:spcPts val="300"/>
-              </a:spcBef>
-            </a:pPr>
-            <a:r>
-              <a:rPr sz="1200">
-                <a:solidFill>
-                  <a:srgbClr val="2C3E50"/>
-                </a:solidFill>
-                <a:latin typeface="Courier New"/>
-              </a:rPr>
-              <a:t>       → full 475k rows</a:t>
+              <a:t>Refit best config on full 475k-row train set</a:t>
             </a:r>
           </a:p>
         </p:txBody>

</xml_diff>

<commit_message>
Add Kaggle data source link to notebook header and title slide
Co-Authored-By: Claude Sonnet 4.6 <noreply@anthropic.com>
</commit_message>
<xml_diff>
--- a/Week 1/Wk1_Capstone/group3.pptx
+++ b/Week 1/Wk1_Capstone/group3.pptx
@@ -3213,7 +3213,7 @@
                 </a:solidFill>
                 <a:latin typeface="Calibri"/>
               </a:rPr>
-              <a:t>ICT6001 — AI Programme | Week 1 Capstone</a:t>
+              <a:t>ICT6001C — AI Programme | Week 1 Capstone</a:t>
             </a:r>
           </a:p>
         </p:txBody>
@@ -3283,7 +3283,7 @@
                 </a:solidFill>
                 <a:latin typeface="Calibri"/>
               </a:rPr>
-              <a:t>  YEO XIU JUAN (ID: 2570777)</a:t>
+              <a:t>  YEO XIU JUAN (ID: 2570472)</a:t>
             </a:r>
           </a:p>
         </p:txBody>
@@ -3318,7 +3318,7 @@
                 </a:solidFill>
                 <a:latin typeface="Calibri"/>
               </a:rPr>
-              <a:t>  LIM KHOON SENG (ID: 2570888)</a:t>
+              <a:t>  LIM KHOON SENG (ID: 2570459)</a:t>
             </a:r>
           </a:p>
         </p:txBody>
@@ -3353,7 +3353,7 @@
                 </a:solidFill>
                 <a:latin typeface="Calibri"/>
               </a:rPr>
-              <a:t>  LAI KIN WAH (ID: 2570999)</a:t>
+              <a:t>  LAI KIN WAH (ID: 2570461)</a:t>
             </a:r>
           </a:p>
         </p:txBody>
@@ -3366,7 +3366,7 @@
         </p:nvSpPr>
         <p:spPr>
           <a:xfrm>
-            <a:off x="411480" y="5852160"/>
+            <a:off x="411480" y="5669280"/>
             <a:ext cx="11368735" cy="320040"/>
           </a:xfrm>
           <a:prstGeom prst="rect">
@@ -3388,7 +3388,7 @@
                 </a:solidFill>
                 <a:latin typeface="Calibri"/>
               </a:rPr>
-              <a:t>Repo :  &lt;repo link&gt;</a:t>
+              <a:t>Repo :  https://github.com/kinwahlai/ICT6001C</a:t>
             </a:r>
           </a:p>
         </p:txBody>
@@ -3401,7 +3401,42 @@
         </p:nvSpPr>
         <p:spPr>
           <a:xfrm>
-            <a:off x="411480" y="6217920"/>
+            <a:off x="411480" y="5989320"/>
+            <a:ext cx="11368735" cy="320040"/>
+          </a:xfrm>
+          <a:prstGeom prst="rect">
+            <a:avLst/>
+          </a:prstGeom>
+          <a:noFill/>
+        </p:spPr>
+        <p:txBody>
+          <a:bodyPr wrap="square">
+            <a:spAutoFit/>
+          </a:bodyPr>
+          <a:lstStyle/>
+          <a:p>
+            <a:pPr algn="l"/>
+            <a:r>
+              <a:rPr sz="1100" b="0" i="0">
+                <a:solidFill>
+                  <a:srgbClr val="2980B9"/>
+                </a:solidFill>
+                <a:latin typeface="Calibri"/>
+              </a:rPr>
+              <a:t>Data :  https://www.kaggle.com/competitions/playground-series-s6e3/data</a:t>
+            </a:r>
+          </a:p>
+        </p:txBody>
+      </p:sp>
+      <p:sp>
+        <p:nvSpPr>
+          <p:cNvPr id="11" name="TextBox 10"/>
+          <p:cNvSpPr txBox="1"/>
+          <p:nvPr/>
+        </p:nvSpPr>
+        <p:spPr>
+          <a:xfrm>
+            <a:off x="411480" y="6309360"/>
             <a:ext cx="11368735" cy="320040"/>
           </a:xfrm>
           <a:prstGeom prst="rect">
@@ -3639,7 +3674,7 @@
                           </a:solidFill>
                           <a:latin typeface="Calibri"/>
                         </a:rPr>
-                        <a:t>2570777</a:t>
+                        <a:t>2570472</a:t>
                       </a:r>
                     </a:p>
                   </a:txBody>
@@ -3687,7 +3722,7 @@
                           </a:solidFill>
                           <a:latin typeface="Calibri"/>
                         </a:rPr>
-                        <a:t>2570888</a:t>
+                        <a:t>2570459</a:t>
                       </a:r>
                     </a:p>
                   </a:txBody>
@@ -3735,7 +3770,7 @@
                           </a:solidFill>
                           <a:latin typeface="Calibri"/>
                         </a:rPr>
-                        <a:t>2570999</a:t>
+                        <a:t>2570461</a:t>
                       </a:r>
                     </a:p>
                   </a:txBody>

</xml_diff>